<commit_message>
Add VIVA Q&A guide (MD & PDF) and updated 10-slide presentation
</commit_message>
<xml_diff>
--- a/presentation/midsem_v2.pptx
+++ b/presentation/midsem_v2.pptx
@@ -5,18 +5,18 @@
     <p:sldMasterId id="2147483648" r:id="rId1"/>
   </p:sldMasterIdLst>
   <p:sldIdLst>
-    <p:sldId id="256" r:id="rId7"/>
-    <p:sldId id="257" r:id="rId8"/>
-    <p:sldId id="258" r:id="rId9"/>
-    <p:sldId id="259" r:id="rId10"/>
-    <p:sldId id="260" r:id="rId11"/>
-    <p:sldId id="261" r:id="rId12"/>
-    <p:sldId id="262" r:id="rId13"/>
-    <p:sldId id="263" r:id="rId14"/>
-    <p:sldId id="264" r:id="rId15"/>
-    <p:sldId id="265" r:id="rId16"/>
+    <p:sldId id="256" r:id="rId2"/>
+    <p:sldId id="257" r:id="rId3"/>
+    <p:sldId id="258" r:id="rId4"/>
+    <p:sldId id="259" r:id="rId5"/>
+    <p:sldId id="260" r:id="rId6"/>
+    <p:sldId id="261" r:id="rId7"/>
+    <p:sldId id="262" r:id="rId8"/>
+    <p:sldId id="263" r:id="rId9"/>
+    <p:sldId id="264" r:id="rId10"/>
+    <p:sldId id="265" r:id="rId11"/>
   </p:sldIdLst>
-  <p:sldSz cx="12188952" cy="6858000" type="screen4x3"/>
+  <p:sldSz cx="12188825" cy="6858000"/>
   <p:notesSz cx="6858000" cy="9144000"/>
   <p:defaultTextStyle>
     <a:defPPr>
@@ -113,6 +113,22 @@
       </a:defRPr>
     </a:lvl9pPr>
   </p:defaultTextStyle>
+  <p:extLst>
+    <p:ext uri="{EFAFB233-063F-42B5-8137-9DF3F51BA10A}">
+      <p15:sldGuideLst xmlns:p15="http://schemas.microsoft.com/office/powerpoint/2012/main">
+        <p15:guide id="1" orient="horz" pos="2160">
+          <p15:clr>
+            <a:srgbClr val="A4A3A4"/>
+          </p15:clr>
+        </p15:guide>
+        <p15:guide id="2" pos="2880">
+          <p15:clr>
+            <a:srgbClr val="A4A3A4"/>
+          </p15:clr>
+        </p15:guide>
+      </p15:sldGuideLst>
+    </p:ext>
+  </p:extLst>
 </p:presentation>
 </file>
 
@@ -154,10 +170,9 @@
           <a:lstStyle/>
           <a:p>
             <a:r>
-              <a:rPr lang="en-US" smtClean="0"/>
+              <a:rPr lang="en-US"/>
               <a:t>Click to edit Master title style</a:t>
             </a:r>
-            <a:endParaRPr lang="en-US"/>
           </a:p>
         </p:txBody>
       </p:sp>
@@ -273,10 +288,9 @@
           </a:lstStyle>
           <a:p>
             <a:r>
-              <a:rPr lang="en-US" smtClean="0"/>
+              <a:rPr lang="en-US"/>
               <a:t>Click to edit Master subtitle style</a:t>
             </a:r>
-            <a:endParaRPr lang="en-US"/>
           </a:p>
         </p:txBody>
       </p:sp>
@@ -297,7 +311,7 @@
           <a:p>
             <a:fld id="{5BCAD085-E8A6-8845-BD4E-CB4CCA059FC4}" type="datetimeFigureOut">
               <a:rPr lang="en-US" smtClean="0"/>
-              <a:t>1/27/13</a:t>
+              <a:t>10/1/2026</a:t>
             </a:fld>
             <a:endParaRPr lang="en-US"/>
           </a:p>
@@ -391,10 +405,9 @@
           <a:lstStyle/>
           <a:p>
             <a:r>
-              <a:rPr lang="en-US" smtClean="0"/>
+              <a:rPr lang="en-US"/>
               <a:t>Click to edit Master title style</a:t>
             </a:r>
-            <a:endParaRPr lang="en-US"/>
           </a:p>
         </p:txBody>
       </p:sp>
@@ -415,38 +428,37 @@
           <a:p>
             <a:pPr lvl="0"/>
             <a:r>
-              <a:rPr lang="en-US" smtClean="0"/>
+              <a:rPr lang="en-US"/>
               <a:t>Click to edit Master text styles</a:t>
             </a:r>
           </a:p>
           <a:p>
             <a:pPr lvl="1"/>
             <a:r>
-              <a:rPr lang="en-US" smtClean="0"/>
+              <a:rPr lang="en-US"/>
               <a:t>Second level</a:t>
             </a:r>
           </a:p>
           <a:p>
             <a:pPr lvl="2"/>
             <a:r>
-              <a:rPr lang="en-US" smtClean="0"/>
+              <a:rPr lang="en-US"/>
               <a:t>Third level</a:t>
             </a:r>
           </a:p>
           <a:p>
             <a:pPr lvl="3"/>
             <a:r>
-              <a:rPr lang="en-US" smtClean="0"/>
+              <a:rPr lang="en-US"/>
               <a:t>Fourth level</a:t>
             </a:r>
           </a:p>
           <a:p>
             <a:pPr lvl="4"/>
             <a:r>
-              <a:rPr lang="en-US" smtClean="0"/>
+              <a:rPr lang="en-US"/>
               <a:t>Fifth level</a:t>
             </a:r>
-            <a:endParaRPr lang="en-US"/>
           </a:p>
         </p:txBody>
       </p:sp>
@@ -467,7 +479,7 @@
           <a:p>
             <a:fld id="{5BCAD085-E8A6-8845-BD4E-CB4CCA059FC4}" type="datetimeFigureOut">
               <a:rPr lang="en-US" smtClean="0"/>
-              <a:t>1/27/13</a:t>
+              <a:t>10/1/2026</a:t>
             </a:fld>
             <a:endParaRPr lang="en-US"/>
           </a:p>
@@ -566,10 +578,9 @@
           <a:lstStyle/>
           <a:p>
             <a:r>
-              <a:rPr lang="en-US" smtClean="0"/>
+              <a:rPr lang="en-US"/>
               <a:t>Click to edit Master title style</a:t>
             </a:r>
-            <a:endParaRPr lang="en-US"/>
           </a:p>
         </p:txBody>
       </p:sp>
@@ -595,38 +606,37 @@
           <a:p>
             <a:pPr lvl="0"/>
             <a:r>
-              <a:rPr lang="en-US" smtClean="0"/>
+              <a:rPr lang="en-US"/>
               <a:t>Click to edit Master text styles</a:t>
             </a:r>
           </a:p>
           <a:p>
             <a:pPr lvl="1"/>
             <a:r>
-              <a:rPr lang="en-US" smtClean="0"/>
+              <a:rPr lang="en-US"/>
               <a:t>Second level</a:t>
             </a:r>
           </a:p>
           <a:p>
             <a:pPr lvl="2"/>
             <a:r>
-              <a:rPr lang="en-US" smtClean="0"/>
+              <a:rPr lang="en-US"/>
               <a:t>Third level</a:t>
             </a:r>
           </a:p>
           <a:p>
             <a:pPr lvl="3"/>
             <a:r>
-              <a:rPr lang="en-US" smtClean="0"/>
+              <a:rPr lang="en-US"/>
               <a:t>Fourth level</a:t>
             </a:r>
           </a:p>
           <a:p>
             <a:pPr lvl="4"/>
             <a:r>
-              <a:rPr lang="en-US" smtClean="0"/>
+              <a:rPr lang="en-US"/>
               <a:t>Fifth level</a:t>
             </a:r>
-            <a:endParaRPr lang="en-US"/>
           </a:p>
         </p:txBody>
       </p:sp>
@@ -647,7 +657,7 @@
           <a:p>
             <a:fld id="{5BCAD085-E8A6-8845-BD4E-CB4CCA059FC4}" type="datetimeFigureOut">
               <a:rPr lang="en-US" smtClean="0"/>
-              <a:t>1/27/13</a:t>
+              <a:t>10/1/2026</a:t>
             </a:fld>
             <a:endParaRPr lang="en-US"/>
           </a:p>
@@ -741,10 +751,9 @@
           <a:lstStyle/>
           <a:p>
             <a:r>
-              <a:rPr lang="en-US" smtClean="0"/>
+              <a:rPr lang="en-US"/>
               <a:t>Click to edit Master title style</a:t>
             </a:r>
-            <a:endParaRPr lang="en-US"/>
           </a:p>
         </p:txBody>
       </p:sp>
@@ -765,38 +774,37 @@
           <a:p>
             <a:pPr lvl="0"/>
             <a:r>
-              <a:rPr lang="en-US" smtClean="0"/>
+              <a:rPr lang="en-US"/>
               <a:t>Click to edit Master text styles</a:t>
             </a:r>
           </a:p>
           <a:p>
             <a:pPr lvl="1"/>
             <a:r>
-              <a:rPr lang="en-US" smtClean="0"/>
+              <a:rPr lang="en-US"/>
               <a:t>Second level</a:t>
             </a:r>
           </a:p>
           <a:p>
             <a:pPr lvl="2"/>
             <a:r>
-              <a:rPr lang="en-US" smtClean="0"/>
+              <a:rPr lang="en-US"/>
               <a:t>Third level</a:t>
             </a:r>
           </a:p>
           <a:p>
             <a:pPr lvl="3"/>
             <a:r>
-              <a:rPr lang="en-US" smtClean="0"/>
+              <a:rPr lang="en-US"/>
               <a:t>Fourth level</a:t>
             </a:r>
           </a:p>
           <a:p>
             <a:pPr lvl="4"/>
             <a:r>
-              <a:rPr lang="en-US" smtClean="0"/>
+              <a:rPr lang="en-US"/>
               <a:t>Fifth level</a:t>
             </a:r>
-            <a:endParaRPr lang="en-US"/>
           </a:p>
         </p:txBody>
       </p:sp>
@@ -817,7 +825,7 @@
           <a:p>
             <a:fld id="{5BCAD085-E8A6-8845-BD4E-CB4CCA059FC4}" type="datetimeFigureOut">
               <a:rPr lang="en-US" smtClean="0"/>
-              <a:t>1/27/13</a:t>
+              <a:t>10/1/2026</a:t>
             </a:fld>
             <a:endParaRPr lang="en-US"/>
           </a:p>
@@ -920,10 +928,9 @@
           </a:lstStyle>
           <a:p>
             <a:r>
-              <a:rPr lang="en-US" smtClean="0"/>
+              <a:rPr lang="en-US"/>
               <a:t>Click to edit Master title style</a:t>
             </a:r>
-            <a:endParaRPr lang="en-US"/>
           </a:p>
         </p:txBody>
       </p:sp>
@@ -1040,7 +1047,7 @@
           <a:p>
             <a:pPr lvl="0"/>
             <a:r>
-              <a:rPr lang="en-US" smtClean="0"/>
+              <a:rPr lang="en-US"/>
               <a:t>Click to edit Master text styles</a:t>
             </a:r>
           </a:p>
@@ -1063,7 +1070,7 @@
           <a:p>
             <a:fld id="{5BCAD085-E8A6-8845-BD4E-CB4CCA059FC4}" type="datetimeFigureOut">
               <a:rPr lang="en-US" smtClean="0"/>
-              <a:t>1/27/13</a:t>
+              <a:t>10/1/2026</a:t>
             </a:fld>
             <a:endParaRPr lang="en-US"/>
           </a:p>
@@ -1157,10 +1164,9 @@
           <a:lstStyle/>
           <a:p>
             <a:r>
-              <a:rPr lang="en-US" smtClean="0"/>
+              <a:rPr lang="en-US"/>
               <a:t>Click to edit Master title style</a:t>
             </a:r>
-            <a:endParaRPr lang="en-US"/>
           </a:p>
         </p:txBody>
       </p:sp>
@@ -1214,38 +1220,37 @@
           <a:p>
             <a:pPr lvl="0"/>
             <a:r>
-              <a:rPr lang="en-US" smtClean="0"/>
+              <a:rPr lang="en-US"/>
               <a:t>Click to edit Master text styles</a:t>
             </a:r>
           </a:p>
           <a:p>
             <a:pPr lvl="1"/>
             <a:r>
-              <a:rPr lang="en-US" smtClean="0"/>
+              <a:rPr lang="en-US"/>
               <a:t>Second level</a:t>
             </a:r>
           </a:p>
           <a:p>
             <a:pPr lvl="2"/>
             <a:r>
-              <a:rPr lang="en-US" smtClean="0"/>
+              <a:rPr lang="en-US"/>
               <a:t>Third level</a:t>
             </a:r>
           </a:p>
           <a:p>
             <a:pPr lvl="3"/>
             <a:r>
-              <a:rPr lang="en-US" smtClean="0"/>
+              <a:rPr lang="en-US"/>
               <a:t>Fourth level</a:t>
             </a:r>
           </a:p>
           <a:p>
             <a:pPr lvl="4"/>
             <a:r>
-              <a:rPr lang="en-US" smtClean="0"/>
+              <a:rPr lang="en-US"/>
               <a:t>Fifth level</a:t>
             </a:r>
-            <a:endParaRPr lang="en-US"/>
           </a:p>
         </p:txBody>
       </p:sp>
@@ -1299,38 +1304,37 @@
           <a:p>
             <a:pPr lvl="0"/>
             <a:r>
-              <a:rPr lang="en-US" smtClean="0"/>
+              <a:rPr lang="en-US"/>
               <a:t>Click to edit Master text styles</a:t>
             </a:r>
           </a:p>
           <a:p>
             <a:pPr lvl="1"/>
             <a:r>
-              <a:rPr lang="en-US" smtClean="0"/>
+              <a:rPr lang="en-US"/>
               <a:t>Second level</a:t>
             </a:r>
           </a:p>
           <a:p>
             <a:pPr lvl="2"/>
             <a:r>
-              <a:rPr lang="en-US" smtClean="0"/>
+              <a:rPr lang="en-US"/>
               <a:t>Third level</a:t>
             </a:r>
           </a:p>
           <a:p>
             <a:pPr lvl="3"/>
             <a:r>
-              <a:rPr lang="en-US" smtClean="0"/>
+              <a:rPr lang="en-US"/>
               <a:t>Fourth level</a:t>
             </a:r>
           </a:p>
           <a:p>
             <a:pPr lvl="4"/>
             <a:r>
-              <a:rPr lang="en-US" smtClean="0"/>
+              <a:rPr lang="en-US"/>
               <a:t>Fifth level</a:t>
             </a:r>
-            <a:endParaRPr lang="en-US"/>
           </a:p>
         </p:txBody>
       </p:sp>
@@ -1351,7 +1355,7 @@
           <a:p>
             <a:fld id="{5BCAD085-E8A6-8845-BD4E-CB4CCA059FC4}" type="datetimeFigureOut">
               <a:rPr lang="en-US" smtClean="0"/>
-              <a:t>1/27/13</a:t>
+              <a:t>10/1/2026</a:t>
             </a:fld>
             <a:endParaRPr lang="en-US"/>
           </a:p>
@@ -1449,10 +1453,9 @@
           </a:lstStyle>
           <a:p>
             <a:r>
-              <a:rPr lang="en-US" smtClean="0"/>
+              <a:rPr lang="en-US"/>
               <a:t>Click to edit Master title style</a:t>
             </a:r>
-            <a:endParaRPr lang="en-US"/>
           </a:p>
         </p:txBody>
       </p:sp>
@@ -1515,7 +1518,7 @@
           <a:p>
             <a:pPr lvl="0"/>
             <a:r>
-              <a:rPr lang="en-US" smtClean="0"/>
+              <a:rPr lang="en-US"/>
               <a:t>Click to edit Master text styles</a:t>
             </a:r>
           </a:p>
@@ -1571,38 +1574,37 @@
           <a:p>
             <a:pPr lvl="0"/>
             <a:r>
-              <a:rPr lang="en-US" smtClean="0"/>
+              <a:rPr lang="en-US"/>
               <a:t>Click to edit Master text styles</a:t>
             </a:r>
           </a:p>
           <a:p>
             <a:pPr lvl="1"/>
             <a:r>
-              <a:rPr lang="en-US" smtClean="0"/>
+              <a:rPr lang="en-US"/>
               <a:t>Second level</a:t>
             </a:r>
           </a:p>
           <a:p>
             <a:pPr lvl="2"/>
             <a:r>
-              <a:rPr lang="en-US" smtClean="0"/>
+              <a:rPr lang="en-US"/>
               <a:t>Third level</a:t>
             </a:r>
           </a:p>
           <a:p>
             <a:pPr lvl="3"/>
             <a:r>
-              <a:rPr lang="en-US" smtClean="0"/>
+              <a:rPr lang="en-US"/>
               <a:t>Fourth level</a:t>
             </a:r>
           </a:p>
           <a:p>
             <a:pPr lvl="4"/>
             <a:r>
-              <a:rPr lang="en-US" smtClean="0"/>
+              <a:rPr lang="en-US"/>
               <a:t>Fifth level</a:t>
             </a:r>
-            <a:endParaRPr lang="en-US"/>
           </a:p>
         </p:txBody>
       </p:sp>
@@ -1665,7 +1667,7 @@
           <a:p>
             <a:pPr lvl="0"/>
             <a:r>
-              <a:rPr lang="en-US" smtClean="0"/>
+              <a:rPr lang="en-US"/>
               <a:t>Click to edit Master text styles</a:t>
             </a:r>
           </a:p>
@@ -1721,38 +1723,37 @@
           <a:p>
             <a:pPr lvl="0"/>
             <a:r>
-              <a:rPr lang="en-US" smtClean="0"/>
+              <a:rPr lang="en-US"/>
               <a:t>Click to edit Master text styles</a:t>
             </a:r>
           </a:p>
           <a:p>
             <a:pPr lvl="1"/>
             <a:r>
-              <a:rPr lang="en-US" smtClean="0"/>
+              <a:rPr lang="en-US"/>
               <a:t>Second level</a:t>
             </a:r>
           </a:p>
           <a:p>
             <a:pPr lvl="2"/>
             <a:r>
-              <a:rPr lang="en-US" smtClean="0"/>
+              <a:rPr lang="en-US"/>
               <a:t>Third level</a:t>
             </a:r>
           </a:p>
           <a:p>
             <a:pPr lvl="3"/>
             <a:r>
-              <a:rPr lang="en-US" smtClean="0"/>
+              <a:rPr lang="en-US"/>
               <a:t>Fourth level</a:t>
             </a:r>
           </a:p>
           <a:p>
             <a:pPr lvl="4"/>
             <a:r>
-              <a:rPr lang="en-US" smtClean="0"/>
+              <a:rPr lang="en-US"/>
               <a:t>Fifth level</a:t>
             </a:r>
-            <a:endParaRPr lang="en-US"/>
           </a:p>
         </p:txBody>
       </p:sp>
@@ -1773,7 +1774,7 @@
           <a:p>
             <a:fld id="{5BCAD085-E8A6-8845-BD4E-CB4CCA059FC4}" type="datetimeFigureOut">
               <a:rPr lang="en-US" smtClean="0"/>
-              <a:t>1/27/13</a:t>
+              <a:t>10/1/2026</a:t>
             </a:fld>
             <a:endParaRPr lang="en-US"/>
           </a:p>
@@ -1867,10 +1868,9 @@
           <a:lstStyle/>
           <a:p>
             <a:r>
-              <a:rPr lang="en-US" smtClean="0"/>
+              <a:rPr lang="en-US"/>
               <a:t>Click to edit Master title style</a:t>
             </a:r>
-            <a:endParaRPr lang="en-US"/>
           </a:p>
         </p:txBody>
       </p:sp>
@@ -1891,7 +1891,7 @@
           <a:p>
             <a:fld id="{5BCAD085-E8A6-8845-BD4E-CB4CCA059FC4}" type="datetimeFigureOut">
               <a:rPr lang="en-US" smtClean="0"/>
-              <a:t>1/27/13</a:t>
+              <a:t>10/1/2026</a:t>
             </a:fld>
             <a:endParaRPr lang="en-US"/>
           </a:p>
@@ -1986,7 +1986,7 @@
           <a:p>
             <a:fld id="{5BCAD085-E8A6-8845-BD4E-CB4CCA059FC4}" type="datetimeFigureOut">
               <a:rPr lang="en-US" smtClean="0"/>
-              <a:t>1/27/13</a:t>
+              <a:t>10/1/2026</a:t>
             </a:fld>
             <a:endParaRPr lang="en-US"/>
           </a:p>
@@ -2089,10 +2089,9 @@
           </a:lstStyle>
           <a:p>
             <a:r>
-              <a:rPr lang="en-US" smtClean="0"/>
+              <a:rPr lang="en-US"/>
               <a:t>Click to edit Master title style</a:t>
             </a:r>
-            <a:endParaRPr lang="en-US"/>
           </a:p>
         </p:txBody>
       </p:sp>
@@ -2146,38 +2145,37 @@
           <a:p>
             <a:pPr lvl="0"/>
             <a:r>
-              <a:rPr lang="en-US" smtClean="0"/>
+              <a:rPr lang="en-US"/>
               <a:t>Click to edit Master text styles</a:t>
             </a:r>
           </a:p>
           <a:p>
             <a:pPr lvl="1"/>
             <a:r>
-              <a:rPr lang="en-US" smtClean="0"/>
+              <a:rPr lang="en-US"/>
               <a:t>Second level</a:t>
             </a:r>
           </a:p>
           <a:p>
             <a:pPr lvl="2"/>
             <a:r>
-              <a:rPr lang="en-US" smtClean="0"/>
+              <a:rPr lang="en-US"/>
               <a:t>Third level</a:t>
             </a:r>
           </a:p>
           <a:p>
             <a:pPr lvl="3"/>
             <a:r>
-              <a:rPr lang="en-US" smtClean="0"/>
+              <a:rPr lang="en-US"/>
               <a:t>Fourth level</a:t>
             </a:r>
           </a:p>
           <a:p>
             <a:pPr lvl="4"/>
             <a:r>
-              <a:rPr lang="en-US" smtClean="0"/>
+              <a:rPr lang="en-US"/>
               <a:t>Fifth level</a:t>
             </a:r>
-            <a:endParaRPr lang="en-US"/>
           </a:p>
         </p:txBody>
       </p:sp>
@@ -2240,7 +2238,7 @@
           <a:p>
             <a:pPr lvl="0"/>
             <a:r>
-              <a:rPr lang="en-US" smtClean="0"/>
+              <a:rPr lang="en-US"/>
               <a:t>Click to edit Master text styles</a:t>
             </a:r>
           </a:p>
@@ -2263,7 +2261,7 @@
           <a:p>
             <a:fld id="{5BCAD085-E8A6-8845-BD4E-CB4CCA059FC4}" type="datetimeFigureOut">
               <a:rPr lang="en-US" smtClean="0"/>
-              <a:t>1/27/13</a:t>
+              <a:t>10/1/2026</a:t>
             </a:fld>
             <a:endParaRPr lang="en-US"/>
           </a:p>
@@ -2366,10 +2364,9 @@
           </a:lstStyle>
           <a:p>
             <a:r>
-              <a:rPr lang="en-US" smtClean="0"/>
+              <a:rPr lang="en-US"/>
               <a:t>Click to edit Master title style</a:t>
             </a:r>
-            <a:endParaRPr lang="en-US"/>
           </a:p>
         </p:txBody>
       </p:sp>
@@ -2493,7 +2490,7 @@
           <a:p>
             <a:pPr lvl="0"/>
             <a:r>
-              <a:rPr lang="en-US" smtClean="0"/>
+              <a:rPr lang="en-US"/>
               <a:t>Click to edit Master text styles</a:t>
             </a:r>
           </a:p>
@@ -2516,7 +2513,7 @@
           <a:p>
             <a:fld id="{5BCAD085-E8A6-8845-BD4E-CB4CCA059FC4}" type="datetimeFigureOut">
               <a:rPr lang="en-US" smtClean="0"/>
-              <a:t>1/27/13</a:t>
+              <a:t>10/1/2026</a:t>
             </a:fld>
             <a:endParaRPr lang="en-US"/>
           </a:p>
@@ -2625,10 +2622,9 @@
           <a:lstStyle/>
           <a:p>
             <a:r>
-              <a:rPr lang="en-US" smtClean="0"/>
+              <a:rPr lang="en-US"/>
               <a:t>Click to edit Master title style</a:t>
             </a:r>
-            <a:endParaRPr lang="en-US"/>
           </a:p>
         </p:txBody>
       </p:sp>
@@ -2659,38 +2655,37 @@
           <a:p>
             <a:pPr lvl="0"/>
             <a:r>
-              <a:rPr lang="en-US" smtClean="0"/>
+              <a:rPr lang="en-US"/>
               <a:t>Click to edit Master text styles</a:t>
             </a:r>
           </a:p>
           <a:p>
             <a:pPr lvl="1"/>
             <a:r>
-              <a:rPr lang="en-US" smtClean="0"/>
+              <a:rPr lang="en-US"/>
               <a:t>Second level</a:t>
             </a:r>
           </a:p>
           <a:p>
             <a:pPr lvl="2"/>
             <a:r>
-              <a:rPr lang="en-US" smtClean="0"/>
+              <a:rPr lang="en-US"/>
               <a:t>Third level</a:t>
             </a:r>
           </a:p>
           <a:p>
             <a:pPr lvl="3"/>
             <a:r>
-              <a:rPr lang="en-US" smtClean="0"/>
+              <a:rPr lang="en-US"/>
               <a:t>Fourth level</a:t>
             </a:r>
           </a:p>
           <a:p>
             <a:pPr lvl="4"/>
             <a:r>
-              <a:rPr lang="en-US" smtClean="0"/>
+              <a:rPr lang="en-US"/>
               <a:t>Fifth level</a:t>
             </a:r>
-            <a:endParaRPr lang="en-US"/>
           </a:p>
         </p:txBody>
       </p:sp>
@@ -2729,7 +2724,7 @@
           <a:p>
             <a:fld id="{5BCAD085-E8A6-8845-BD4E-CB4CCA059FC4}" type="datetimeFigureOut">
               <a:rPr lang="en-US" smtClean="0"/>
-              <a:t>1/27/13</a:t>
+              <a:t>10/1/2026</a:t>
             </a:fld>
             <a:endParaRPr lang="en-US"/>
           </a:p>
@@ -3088,7 +3083,7 @@
 </file>
 
 <file path=ppt/slides/slide1.xml><?xml version="1.0" encoding="utf-8"?>
-<p:sld xmlns:a="http://schemas.openxmlformats.org/drawingml/2006/main" xmlns:p="http://schemas.openxmlformats.org/presentationml/2006/main" xmlns:r="http://schemas.openxmlformats.org/officeDocument/2006/relationships">
+<p:sld xmlns:a="http://schemas.openxmlformats.org/drawingml/2006/main" xmlns:r="http://schemas.openxmlformats.org/officeDocument/2006/relationships" xmlns:p="http://schemas.openxmlformats.org/presentationml/2006/main">
   <p:cSld>
     <p:bg>
       <p:bgPr>
@@ -3104,50 +3099,14 @@
         <p:cNvGrpSpPr/>
         <p:nvPr/>
       </p:nvGrpSpPr>
-      <p:grpSpPr/>
-      <p:sp>
-        <p:nvSpPr>
-          <p:cNvPr id="2" name="Rectangle 1"/>
-          <p:cNvSpPr/>
-          <p:nvPr/>
-        </p:nvSpPr>
-        <p:spPr>
-          <a:xfrm>
-            <a:off x="0" y="0"/>
-            <a:ext cx="12188952" cy="164592"/>
-          </a:xfrm>
-          <a:prstGeom prst="rect">
-            <a:avLst/>
-          </a:prstGeom>
-          <a:solidFill>
-            <a:srgbClr val="E33B2E"/>
-          </a:solidFill>
-          <a:ln>
-            <a:noFill/>
-          </a:ln>
-        </p:spPr>
-        <p:style>
-          <a:lnRef idx="1">
-            <a:schemeClr val="accent1"/>
-          </a:lnRef>
-          <a:fillRef idx="3">
-            <a:schemeClr val="accent1"/>
-          </a:fillRef>
-          <a:effectRef idx="2">
-            <a:schemeClr val="accent1"/>
-          </a:effectRef>
-          <a:fontRef idx="minor">
-            <a:schemeClr val="lt1"/>
-          </a:fontRef>
-        </p:style>
-        <p:txBody>
-          <a:bodyPr rtlCol="0" anchor="ctr"/>
-          <a:lstStyle/>
-          <a:p>
-            <a:pPr algn="ctr"/>
-          </a:p>
-        </p:txBody>
-      </p:sp>
+      <p:grpSpPr>
+        <a:xfrm>
+          <a:off x="0" y="0"/>
+          <a:ext cx="0" cy="0"/>
+          <a:chOff x="0" y="0"/>
+          <a:chExt cx="0" cy="0"/>
+        </a:xfrm>
+      </p:grpSpPr>
       <p:sp>
         <p:nvSpPr>
           <p:cNvPr id="3" name="Rectangle 2"/>
@@ -3188,6 +3147,7 @@
           <a:lstStyle/>
           <a:p>
             <a:pPr algn="ctr"/>
+            <a:endParaRPr/>
           </a:p>
         </p:txBody>
       </p:sp>
@@ -3199,8 +3159,8 @@
         </p:nvSpPr>
         <p:spPr>
           <a:xfrm>
-            <a:off x="457200" y="320040"/>
-            <a:ext cx="11247120" cy="502920"/>
+            <a:off x="457200" y="452710"/>
+            <a:ext cx="11247120" cy="415498"/>
           </a:xfrm>
           <a:prstGeom prst="rect">
             <a:avLst/>
@@ -3215,7 +3175,7 @@
           <a:p>
             <a:pPr algn="ctr"/>
             <a:r>
-              <a:rPr sz="2000" b="1" i="0">
+              <a:rPr sz="2100" b="1" i="0" dirty="0">
                 <a:solidFill>
                   <a:srgbClr val="1A376C"/>
                 </a:solidFill>
@@ -3233,8 +3193,8 @@
         </p:nvSpPr>
         <p:spPr>
           <a:xfrm>
-            <a:off x="457200" y="1188720"/>
-            <a:ext cx="11247120" cy="868680"/>
+            <a:off x="470852" y="1957036"/>
+            <a:ext cx="11247120" cy="584775"/>
           </a:xfrm>
           <a:prstGeom prst="rect">
             <a:avLst/>
@@ -3249,7 +3209,7 @@
           <a:p>
             <a:pPr algn="ctr"/>
             <a:r>
-              <a:rPr sz="4400" b="1" i="0">
+              <a:rPr sz="3200" b="1" i="0" dirty="0">
                 <a:solidFill>
                   <a:srgbClr val="1A376C"/>
                 </a:solidFill>
@@ -3267,8 +3227,8 @@
         </p:nvSpPr>
         <p:spPr>
           <a:xfrm>
-            <a:off x="457200" y="1920240"/>
-            <a:ext cx="11247120" cy="685800"/>
+            <a:off x="470852" y="1141655"/>
+            <a:ext cx="11247120" cy="769441"/>
           </a:xfrm>
           <a:prstGeom prst="rect">
             <a:avLst/>
@@ -3283,9 +3243,12 @@
           <a:p>
             <a:pPr algn="ctr"/>
             <a:r>
-              <a:rPr sz="3400" b="0" i="0">
-                <a:solidFill>
-                  <a:srgbClr val="E33B2E"/>
+              <a:rPr sz="4400" b="0" i="0" dirty="0">
+                <a:solidFill>
+                  <a:schemeClr val="tx1">
+                    <a:lumMod val="95000"/>
+                    <a:lumOff val="5000"/>
+                  </a:schemeClr>
                 </a:solidFill>
               </a:rPr>
               <a:t>Semantic S2S vs. S2T2S Pipelines</a:t>
@@ -3333,6 +3296,7 @@
           <a:lstStyle/>
           <a:p>
             <a:pPr algn="ctr"/>
+            <a:endParaRPr/>
           </a:p>
         </p:txBody>
       </p:sp>
@@ -3344,7 +3308,41 @@
         </p:nvSpPr>
         <p:spPr>
           <a:xfrm>
-            <a:off x="457200" y="2834640"/>
+            <a:off x="457200" y="3269775"/>
+            <a:ext cx="11247120" cy="430887"/>
+          </a:xfrm>
+          <a:prstGeom prst="rect">
+            <a:avLst/>
+          </a:prstGeom>
+          <a:noFill/>
+        </p:spPr>
+        <p:txBody>
+          <a:bodyPr wrap="square">
+            <a:spAutoFit/>
+          </a:bodyPr>
+          <a:lstStyle/>
+          <a:p>
+            <a:pPr algn="ctr"/>
+            <a:r>
+              <a:rPr sz="2200" b="0" i="0" dirty="0">
+                <a:solidFill>
+                  <a:srgbClr val="000000"/>
+                </a:solidFill>
+              </a:rPr>
+              <a:t>Project — Mid-Semester Evaluation</a:t>
+            </a:r>
+          </a:p>
+        </p:txBody>
+      </p:sp>
+      <p:sp>
+        <p:nvSpPr>
+          <p:cNvPr id="9" name="TextBox 8"/>
+          <p:cNvSpPr txBox="1"/>
+          <p:nvPr/>
+        </p:nvSpPr>
+        <p:spPr>
+          <a:xfrm>
+            <a:off x="457200" y="3772695"/>
             <a:ext cx="11247120" cy="502920"/>
           </a:xfrm>
           <a:prstGeom prst="rect">
@@ -3360,26 +3358,32 @@
           <a:p>
             <a:pPr algn="ctr"/>
             <a:r>
-              <a:rPr sz="2200" b="0" i="0">
-                <a:solidFill>
-                  <a:srgbClr val="000000"/>
-                </a:solidFill>
-              </a:rPr>
-              <a:t>Minor Project — Mid-Semester Evaluation</a:t>
-            </a:r>
-          </a:p>
-        </p:txBody>
-      </p:sp>
-      <p:sp>
-        <p:nvSpPr>
-          <p:cNvPr id="9" name="TextBox 8"/>
+              <a:rPr sz="2000" b="0" i="0" dirty="0">
+                <a:solidFill>
+                  <a:srgbClr val="444444"/>
+                </a:solidFill>
+              </a:rPr>
+              <a:t>End-to-End Semantic Speech Communication over Wireless Channels</a:t>
+            </a:r>
+          </a:p>
+        </p:txBody>
+      </p:sp>
+      <p:sp>
+        <p:nvSpPr>
+          <p:cNvPr id="13" name="TextBox 12">
+            <a:extLst>
+              <a:ext uri="{FF2B5EF4-FFF2-40B4-BE49-F238E27FC236}">
+                <a16:creationId xmlns:a16="http://schemas.microsoft.com/office/drawing/2014/main" id="{99E32B19-9022-E90D-C0FC-6C2A00254101}"/>
+              </a:ext>
+            </a:extLst>
+          </p:cNvPr>
           <p:cNvSpPr txBox="1"/>
           <p:nvPr/>
         </p:nvSpPr>
         <p:spPr>
           <a:xfrm>
-            <a:off x="457200" y="3337560"/>
-            <a:ext cx="11247120" cy="502920"/>
+            <a:off x="110067" y="5065789"/>
+            <a:ext cx="4936067" cy="1446550"/>
           </a:xfrm>
           <a:prstGeom prst="rect">
             <a:avLst/>
@@ -3392,28 +3396,99 @@
           </a:bodyPr>
           <a:lstStyle/>
           <a:p>
-            <a:pPr algn="ctr"/>
-            <a:r>
-              <a:rPr sz="2000" b="0" i="0">
-                <a:solidFill>
-                  <a:srgbClr val="444444"/>
-                </a:solidFill>
-              </a:rPr>
-              <a:t>End-to-End Semantic Speech Communication over Wireless Channels</a:t>
-            </a:r>
-          </a:p>
-        </p:txBody>
-      </p:sp>
-      <p:sp>
-        <p:nvSpPr>
-          <p:cNvPr id="10" name="TextBox 9"/>
+            <a:r>
+              <a:rPr lang="en-US" sz="2200" b="0" i="0" dirty="0">
+                <a:solidFill>
+                  <a:srgbClr val="000000"/>
+                </a:solidFill>
+              </a:rPr>
+              <a:t>Submitted By : </a:t>
+            </a:r>
+            <a:br>
+              <a:rPr lang="en-US" sz="2200" b="0" i="0" dirty="0">
+                <a:solidFill>
+                  <a:srgbClr val="000000"/>
+                </a:solidFill>
+              </a:rPr>
+            </a:br>
+            <a:r>
+              <a:rPr lang="en-US" sz="2200" b="0" i="0" dirty="0" err="1">
+                <a:solidFill>
+                  <a:srgbClr val="000000"/>
+                </a:solidFill>
+              </a:rPr>
+              <a:t>Yarkala</a:t>
+            </a:r>
+            <a:r>
+              <a:rPr lang="en-US" sz="2200" b="0" i="0" dirty="0">
+                <a:solidFill>
+                  <a:srgbClr val="000000"/>
+                </a:solidFill>
+              </a:rPr>
+              <a:t> Siddhartha (IEC2023039)</a:t>
+            </a:r>
+            <a:br>
+              <a:rPr lang="en-US" sz="2200" b="0" i="0" dirty="0">
+                <a:solidFill>
+                  <a:srgbClr val="000000"/>
+                </a:solidFill>
+              </a:rPr>
+            </a:br>
+            <a:r>
+              <a:rPr lang="en-US" sz="2200" b="0" i="0" dirty="0">
+                <a:solidFill>
+                  <a:srgbClr val="000000"/>
+                </a:solidFill>
+              </a:rPr>
+              <a:t>Adarsh Kumar(IEC2023040)</a:t>
+            </a:r>
+            <a:br>
+              <a:rPr lang="en-US" sz="2200" b="0" i="0" dirty="0">
+                <a:solidFill>
+                  <a:srgbClr val="000000"/>
+                </a:solidFill>
+              </a:rPr>
+            </a:br>
+            <a:r>
+              <a:rPr lang="en-US" sz="2200" b="0" i="0" dirty="0" err="1">
+                <a:solidFill>
+                  <a:srgbClr val="000000"/>
+                </a:solidFill>
+              </a:rPr>
+              <a:t>Chelpuri</a:t>
+            </a:r>
+            <a:r>
+              <a:rPr lang="en-US" sz="2200" b="0" i="0" dirty="0">
+                <a:solidFill>
+                  <a:srgbClr val="000000"/>
+                </a:solidFill>
+              </a:rPr>
+              <a:t> Sumithra Devi(IEC2023112)</a:t>
+            </a:r>
+            <a:endParaRPr sz="2200" b="0" i="0" dirty="0">
+              <a:solidFill>
+                <a:srgbClr val="000000"/>
+              </a:solidFill>
+            </a:endParaRPr>
+          </a:p>
+        </p:txBody>
+      </p:sp>
+      <p:sp>
+        <p:nvSpPr>
+          <p:cNvPr id="15" name="TextBox 14">
+            <a:extLst>
+              <a:ext uri="{FF2B5EF4-FFF2-40B4-BE49-F238E27FC236}">
+                <a16:creationId xmlns:a16="http://schemas.microsoft.com/office/drawing/2014/main" id="{4D93637E-A3FF-DE4B-EAF6-3D2C0FA04290}"/>
+              </a:ext>
+            </a:extLst>
+          </p:cNvPr>
           <p:cNvSpPr txBox="1"/>
           <p:nvPr/>
         </p:nvSpPr>
         <p:spPr>
           <a:xfrm>
-            <a:off x="457200" y="3977639"/>
-            <a:ext cx="11247120" cy="457200"/>
+            <a:off x="7142691" y="5065789"/>
+            <a:ext cx="4936067" cy="1446550"/>
           </a:xfrm>
           <a:prstGeom prst="rect">
             <a:avLst/>
@@ -3426,49 +3501,58 @@
           </a:bodyPr>
           <a:lstStyle/>
           <a:p>
-            <a:pPr algn="ctr"/>
-            <a:r>
-              <a:rPr sz="1700" b="0" i="0">
-                <a:solidFill>
-                  <a:srgbClr val="555555"/>
-                </a:solidFill>
-              </a:rPr>
-              <a:t>Pipeline Stack:  FunASR SenseVoice   •   DeepSC Transformer   •   Kokoro-82M TTS   •   AWGN / Rayleigh / Rician Channels</a:t>
-            </a:r>
-          </a:p>
-        </p:txBody>
-      </p:sp>
-      <p:sp>
-        <p:nvSpPr>
-          <p:cNvPr id="11" name="TextBox 10"/>
-          <p:cNvSpPr txBox="1"/>
-          <p:nvPr/>
-        </p:nvSpPr>
-        <p:spPr>
-          <a:xfrm>
-            <a:off x="457200" y="4572000"/>
-            <a:ext cx="11247120" cy="457200"/>
-          </a:xfrm>
-          <a:prstGeom prst="rect">
-            <a:avLst/>
-          </a:prstGeom>
-          <a:noFill/>
-        </p:spPr>
-        <p:txBody>
-          <a:bodyPr wrap="square">
-            <a:spAutoFit/>
-          </a:bodyPr>
-          <a:lstStyle/>
-          <a:p>
-            <a:pPr algn="ctr"/>
-            <a:r>
-              <a:rPr sz="1800" b="0" i="0">
+            <a:pPr algn="r"/>
+            <a:r>
+              <a:rPr lang="en-US" sz="2200" b="0" i="0" dirty="0">
                 <a:solidFill>
                   <a:srgbClr val="000000"/>
                 </a:solidFill>
               </a:rPr>
-              <a:t>October 2026</a:t>
-            </a:r>
+              <a:t>Submitted To: </a:t>
+            </a:r>
+            <a:br>
+              <a:rPr lang="en-US" sz="2200" b="0" i="0" dirty="0">
+                <a:solidFill>
+                  <a:srgbClr val="000000"/>
+                </a:solidFill>
+              </a:rPr>
+            </a:br>
+            <a:endParaRPr lang="en-US" sz="2200" b="0" i="0" dirty="0">
+              <a:solidFill>
+                <a:srgbClr val="000000"/>
+              </a:solidFill>
+            </a:endParaRPr>
+          </a:p>
+          <a:p>
+            <a:pPr algn="r"/>
+            <a:r>
+              <a:rPr lang="en-US" sz="2200" dirty="0">
+                <a:solidFill>
+                  <a:srgbClr val="000000"/>
+                </a:solidFill>
+              </a:rPr>
+              <a:t>Radhika Gour</a:t>
+            </a:r>
+            <a:br>
+              <a:rPr lang="en-US" sz="2200" dirty="0">
+                <a:solidFill>
+                  <a:srgbClr val="000000"/>
+                </a:solidFill>
+              </a:rPr>
+            </a:br>
+            <a:r>
+              <a:rPr lang="en-US" sz="2200" dirty="0">
+                <a:solidFill>
+                  <a:srgbClr val="000000"/>
+                </a:solidFill>
+              </a:rPr>
+              <a:t>Department of ECE, IIITA</a:t>
+            </a:r>
+            <a:endParaRPr sz="2200" b="0" i="0" dirty="0">
+              <a:solidFill>
+                <a:srgbClr val="000000"/>
+              </a:solidFill>
+            </a:endParaRPr>
           </a:p>
         </p:txBody>
       </p:sp>
@@ -3481,7 +3565,7 @@
 </file>
 
 <file path=ppt/slides/slide10.xml><?xml version="1.0" encoding="utf-8"?>
-<p:sld xmlns:a="http://schemas.openxmlformats.org/drawingml/2006/main" xmlns:p="http://schemas.openxmlformats.org/presentationml/2006/main" xmlns:r="http://schemas.openxmlformats.org/officeDocument/2006/relationships">
+<p:sld xmlns:a="http://schemas.openxmlformats.org/drawingml/2006/main" xmlns:r="http://schemas.openxmlformats.org/officeDocument/2006/relationships" xmlns:p="http://schemas.openxmlformats.org/presentationml/2006/main">
   <p:cSld>
     <p:bg>
       <p:bgPr>
@@ -3497,7 +3581,14 @@
         <p:cNvGrpSpPr/>
         <p:nvPr/>
       </p:nvGrpSpPr>
-      <p:grpSpPr/>
+      <p:grpSpPr>
+        <a:xfrm>
+          <a:off x="0" y="0"/>
+          <a:ext cx="0" cy="0"/>
+          <a:chOff x="0" y="0"/>
+          <a:chExt cx="0" cy="0"/>
+        </a:xfrm>
+      </p:grpSpPr>
       <p:sp>
         <p:nvSpPr>
           <p:cNvPr id="2" name="Rectangle 1"/>
@@ -3538,6 +3629,7 @@
           <a:lstStyle/>
           <a:p>
             <a:pPr algn="ctr"/>
+            <a:endParaRPr/>
           </a:p>
         </p:txBody>
       </p:sp>
@@ -3727,7 +3819,7 @@
 </file>
 
 <file path=ppt/slides/slide2.xml><?xml version="1.0" encoding="utf-8"?>
-<p:sld xmlns:a="http://schemas.openxmlformats.org/drawingml/2006/main" xmlns:p="http://schemas.openxmlformats.org/presentationml/2006/main" xmlns:r="http://schemas.openxmlformats.org/officeDocument/2006/relationships">
+<p:sld xmlns:a="http://schemas.openxmlformats.org/drawingml/2006/main" xmlns:r="http://schemas.openxmlformats.org/officeDocument/2006/relationships" xmlns:p="http://schemas.openxmlformats.org/presentationml/2006/main">
   <p:cSld>
     <p:bg>
       <p:bgPr>
@@ -3743,7 +3835,14 @@
         <p:cNvGrpSpPr/>
         <p:nvPr/>
       </p:nvGrpSpPr>
-      <p:grpSpPr/>
+      <p:grpSpPr>
+        <a:xfrm>
+          <a:off x="0" y="0"/>
+          <a:ext cx="0" cy="0"/>
+          <a:chOff x="0" y="0"/>
+          <a:chExt cx="0" cy="0"/>
+        </a:xfrm>
+      </p:grpSpPr>
       <p:sp>
         <p:nvSpPr>
           <p:cNvPr id="2" name="Rectangle 1"/>
@@ -3784,6 +3883,7 @@
           <a:lstStyle/>
           <a:p>
             <a:pPr algn="ctr"/>
+            <a:endParaRPr/>
           </a:p>
         </p:txBody>
       </p:sp>
@@ -3830,7 +3930,7 @@
         <p:spPr>
           <a:xfrm>
             <a:off x="365760" y="1188720"/>
-            <a:ext cx="11430000" cy="5303520"/>
+            <a:ext cx="11430000" cy="5565626"/>
           </a:xfrm>
           <a:prstGeom prst="rect">
             <a:avLst/>
@@ -3849,7 +3949,7 @@
               </a:spcBef>
             </a:pPr>
             <a:r>
-              <a:rPr sz="2300" b="1">
+              <a:rPr sz="2100" b="1" dirty="0">
                 <a:solidFill>
                   <a:srgbClr val="1A376C"/>
                 </a:solidFill>
@@ -3864,7 +3964,7 @@
               </a:spcBef>
             </a:pPr>
             <a:r>
-              <a:rPr sz="2200" b="0">
+              <a:rPr sz="2100" b="0" dirty="0">
                 <a:solidFill>
                   <a:srgbClr val="000000"/>
                 </a:solidFill>
@@ -3879,7 +3979,7 @@
               </a:spcBef>
             </a:pPr>
             <a:r>
-              <a:rPr sz="2200" b="0">
+              <a:rPr sz="2100" b="0" dirty="0">
                 <a:solidFill>
                   <a:srgbClr val="000000"/>
                 </a:solidFill>
@@ -3894,7 +3994,7 @@
               </a:spcBef>
             </a:pPr>
             <a:r>
-              <a:rPr sz="2200" b="0">
+              <a:rPr sz="2100" b="0" dirty="0">
                 <a:solidFill>
                   <a:srgbClr val="000000"/>
                 </a:solidFill>
@@ -3908,6 +4008,11 @@
                 <a:spcPts val="400"/>
               </a:spcBef>
             </a:pPr>
+            <a:endParaRPr sz="2100" b="0" dirty="0">
+              <a:solidFill>
+                <a:srgbClr val="000000"/>
+              </a:solidFill>
+            </a:endParaRPr>
           </a:p>
           <a:p>
             <a:pPr algn="l">
@@ -3916,7 +4021,7 @@
               </a:spcBef>
             </a:pPr>
             <a:r>
-              <a:rPr sz="2300" b="1">
+              <a:rPr sz="2100" b="1" dirty="0">
                 <a:solidFill>
                   <a:srgbClr val="1A376C"/>
                 </a:solidFill>
@@ -3931,7 +4036,7 @@
               </a:spcBef>
             </a:pPr>
             <a:r>
-              <a:rPr sz="2200" b="0">
+              <a:rPr sz="2100" b="0" dirty="0">
                 <a:solidFill>
                   <a:srgbClr val="000000"/>
                 </a:solidFill>
@@ -3946,7 +4051,7 @@
               </a:spcBef>
             </a:pPr>
             <a:r>
-              <a:rPr sz="2200" b="0">
+              <a:rPr sz="2100" b="0" dirty="0">
                 <a:solidFill>
                   <a:srgbClr val="000000"/>
                 </a:solidFill>
@@ -3960,6 +4065,11 @@
                 <a:spcPts val="400"/>
               </a:spcBef>
             </a:pPr>
+            <a:endParaRPr sz="2100" b="0" dirty="0">
+              <a:solidFill>
+                <a:srgbClr val="000000"/>
+              </a:solidFill>
+            </a:endParaRPr>
           </a:p>
           <a:p>
             <a:pPr algn="l">
@@ -3968,7 +4078,7 @@
               </a:spcBef>
             </a:pPr>
             <a:r>
-              <a:rPr sz="2300" b="1">
+              <a:rPr sz="2100" b="1" dirty="0">
                 <a:solidFill>
                   <a:srgbClr val="1A376C"/>
                 </a:solidFill>
@@ -3983,13 +4093,26 @@
               </a:spcBef>
             </a:pPr>
             <a:r>
-              <a:rPr sz="2200" b="0">
+              <a:rPr sz="2100" b="0" dirty="0">
                 <a:solidFill>
                   <a:srgbClr val="000000"/>
                 </a:solidFill>
               </a:rPr>
-              <a:t>• On modern 4G/5G networks, transmitting 1 KB of data takes &lt; 3 ms</a:t>
-            </a:r>
+              <a:t>• On modern 4G/5G networks, transmitting 1 KB of data takes &lt; 3 </a:t>
+            </a:r>
+            <a:r>
+              <a:rPr sz="2100" b="0" dirty="0" err="1">
+                <a:solidFill>
+                  <a:srgbClr val="000000"/>
+                </a:solidFill>
+              </a:rPr>
+              <a:t>ms</a:t>
+            </a:r>
+            <a:endParaRPr sz="2100" b="0" dirty="0">
+              <a:solidFill>
+                <a:srgbClr val="000000"/>
+              </a:solidFill>
+            </a:endParaRPr>
           </a:p>
           <a:p>
             <a:pPr algn="l">
@@ -3998,12 +4121,28 @@
               </a:spcBef>
             </a:pPr>
             <a:r>
-              <a:rPr sz="2200" b="0">
+              <a:rPr sz="2100" b="0" dirty="0">
                 <a:solidFill>
                   <a:srgbClr val="000000"/>
                 </a:solidFill>
               </a:rPr>
-              <a:t>• Transmission delay ≈ 0 ms  →  all delay is from computation &amp; buffering</a:t>
+              <a:t>• Transmission delay ≈ 0 </a:t>
+            </a:r>
+            <a:r>
+              <a:rPr sz="2100" b="0" dirty="0" err="1">
+                <a:solidFill>
+                  <a:srgbClr val="000000"/>
+                </a:solidFill>
+              </a:rPr>
+              <a:t>ms</a:t>
+            </a:r>
+            <a:r>
+              <a:rPr sz="2100" b="0" dirty="0">
+                <a:solidFill>
+                  <a:srgbClr val="000000"/>
+                </a:solidFill>
+              </a:rPr>
+              <a:t>  →  all delay is from computation &amp; buffering</a:t>
             </a:r>
           </a:p>
           <a:p>
@@ -4013,12 +4152,28 @@
               </a:spcBef>
             </a:pPr>
             <a:r>
-              <a:rPr sz="2200" b="0">
+              <a:rPr sz="2100" b="0" dirty="0">
                 <a:solidFill>
                   <a:srgbClr val="000000"/>
                 </a:solidFill>
               </a:rPr>
-              <a:t>• ITU-T G.114 standard: voice delay must be &lt; 200 ms for natural conversation</a:t>
+              <a:t>• ITU-T G.114 standard: voice delay must be &lt; 200 </a:t>
+            </a:r>
+            <a:r>
+              <a:rPr sz="2100" b="0" dirty="0" err="1">
+                <a:solidFill>
+                  <a:srgbClr val="000000"/>
+                </a:solidFill>
+              </a:rPr>
+              <a:t>ms</a:t>
+            </a:r>
+            <a:r>
+              <a:rPr sz="2100" b="0" dirty="0">
+                <a:solidFill>
+                  <a:srgbClr val="000000"/>
+                </a:solidFill>
+              </a:rPr>
+              <a:t> for natural conversation</a:t>
             </a:r>
           </a:p>
           <a:p>
@@ -4028,12 +4183,28 @@
               </a:spcBef>
             </a:pPr>
             <a:r>
-              <a:rPr sz="2200" b="0">
+              <a:rPr sz="2100" b="0" dirty="0">
                 <a:solidFill>
                   <a:srgbClr val="000000"/>
                 </a:solidFill>
               </a:rPr>
-              <a:t>• S2T2S achieves lower bandwidth BUT causes 5,000 – 29,000 ms of latency!</a:t>
+              <a:t>• S2T2S achieves lower bandwidth BUT causes 5,000 – 29,000 </a:t>
+            </a:r>
+            <a:r>
+              <a:rPr sz="2100" b="0" dirty="0" err="1">
+                <a:solidFill>
+                  <a:srgbClr val="000000"/>
+                </a:solidFill>
+              </a:rPr>
+              <a:t>ms</a:t>
+            </a:r>
+            <a:r>
+              <a:rPr sz="2100" b="0" dirty="0">
+                <a:solidFill>
+                  <a:srgbClr val="000000"/>
+                </a:solidFill>
+              </a:rPr>
+              <a:t> of latency!</a:t>
             </a:r>
           </a:p>
         </p:txBody>
@@ -4047,7 +4218,7 @@
 </file>
 
 <file path=ppt/slides/slide3.xml><?xml version="1.0" encoding="utf-8"?>
-<p:sld xmlns:a="http://schemas.openxmlformats.org/drawingml/2006/main" xmlns:p="http://schemas.openxmlformats.org/presentationml/2006/main" xmlns:r="http://schemas.openxmlformats.org/officeDocument/2006/relationships">
+<p:sld xmlns:a="http://schemas.openxmlformats.org/drawingml/2006/main" xmlns:r="http://schemas.openxmlformats.org/officeDocument/2006/relationships" xmlns:p="http://schemas.openxmlformats.org/presentationml/2006/main">
   <p:cSld>
     <p:bg>
       <p:bgPr>
@@ -4063,7 +4234,14 @@
         <p:cNvGrpSpPr/>
         <p:nvPr/>
       </p:nvGrpSpPr>
-      <p:grpSpPr/>
+      <p:grpSpPr>
+        <a:xfrm>
+          <a:off x="0" y="0"/>
+          <a:ext cx="0" cy="0"/>
+          <a:chOff x="0" y="0"/>
+          <a:chExt cx="0" cy="0"/>
+        </a:xfrm>
+      </p:grpSpPr>
       <p:sp>
         <p:nvSpPr>
           <p:cNvPr id="2" name="Rectangle 1"/>
@@ -4104,6 +4282,7 @@
           <a:lstStyle/>
           <a:p>
             <a:pPr algn="ctr"/>
+            <a:endParaRPr/>
           </a:p>
         </p:txBody>
       </p:sp>
@@ -4183,6 +4362,7 @@
           <a:lstStyle/>
           <a:p>
             <a:pPr algn="ctr"/>
+            <a:endParaRPr/>
           </a:p>
         </p:txBody>
       </p:sp>
@@ -4210,12 +4390,28 @@
           <a:p>
             <a:pPr algn="l"/>
             <a:r>
-              <a:rPr sz="2000" b="1" i="0">
+              <a:rPr sz="2000" b="1" i="0" dirty="0">
                 <a:solidFill>
                   <a:srgbClr val="1A376C"/>
                 </a:solidFill>
               </a:rPr>
-              <a:t>Pipeline B — Cascade S2T2S  (Our Implementation)</a:t>
+              <a:t>Pipeline </a:t>
+            </a:r>
+            <a:r>
+              <a:rPr lang="en-US" sz="2000" b="1" i="0" dirty="0">
+                <a:solidFill>
+                  <a:srgbClr val="1A376C"/>
+                </a:solidFill>
+              </a:rPr>
+              <a:t>A</a:t>
+            </a:r>
+            <a:r>
+              <a:rPr sz="2000" b="1" i="0" dirty="0">
+                <a:solidFill>
+                  <a:srgbClr val="1A376C"/>
+                </a:solidFill>
+              </a:rPr>
+              <a:t> — Cascade S2T2S  (Our Implementation)</a:t>
             </a:r>
           </a:p>
         </p:txBody>
@@ -4244,12 +4440,60 @@
           <a:p>
             <a:pPr algn="l"/>
             <a:r>
-              <a:rPr sz="1800" b="0" i="0">
+              <a:rPr sz="1800" b="0" i="0" dirty="0">
                 <a:solidFill>
                   <a:srgbClr val="000000"/>
                 </a:solidFill>
               </a:rPr>
-              <a:t>Mic Input  →  SenseVoice ASR (buffers full phrase)  →  Text + Emotion + Gender  →  DeepSC Encoder  →  Wireless Channel (AWGN / Rayleigh / Rician)  →  DeepSC Decoder  →  Kokoro TTS (needs full sentence)  →  Speaker Output</a:t>
+              <a:t>Mic Input  →  </a:t>
+            </a:r>
+            <a:r>
+              <a:rPr sz="1800" b="0" i="0" dirty="0" err="1">
+                <a:solidFill>
+                  <a:srgbClr val="000000"/>
+                </a:solidFill>
+              </a:rPr>
+              <a:t>SenseVoice</a:t>
+            </a:r>
+            <a:r>
+              <a:rPr sz="1800" b="0" i="0" dirty="0">
+                <a:solidFill>
+                  <a:srgbClr val="000000"/>
+                </a:solidFill>
+              </a:rPr>
+              <a:t> ASR (buffers full phrase)  →  Text + Emotion + Gender  →  </a:t>
+            </a:r>
+            <a:r>
+              <a:rPr sz="1800" b="0" i="0" dirty="0" err="1">
+                <a:solidFill>
+                  <a:srgbClr val="000000"/>
+                </a:solidFill>
+              </a:rPr>
+              <a:t>DeepSC</a:t>
+            </a:r>
+            <a:r>
+              <a:rPr sz="1800" b="0" i="0" dirty="0">
+                <a:solidFill>
+                  <a:srgbClr val="000000"/>
+                </a:solidFill>
+              </a:rPr>
+              <a:t> Encoder  →  Wireless Channel (AWGN / Rayleigh / Rician)  →  </a:t>
+            </a:r>
+            <a:r>
+              <a:rPr sz="1800" b="0" i="0" dirty="0" err="1">
+                <a:solidFill>
+                  <a:srgbClr val="000000"/>
+                </a:solidFill>
+              </a:rPr>
+              <a:t>DeepSC</a:t>
+            </a:r>
+            <a:r>
+              <a:rPr sz="1800" b="0" i="0" dirty="0">
+                <a:solidFill>
+                  <a:srgbClr val="000000"/>
+                </a:solidFill>
+              </a:rPr>
+              <a:t> Decoder  →  Kokoro TTS (needs full sentence)  →  Speaker Output</a:t>
             </a:r>
           </a:p>
         </p:txBody>
@@ -4278,7 +4522,7 @@
           <a:p>
             <a:pPr algn="l"/>
             <a:r>
-              <a:rPr sz="1600" b="0" i="0">
+              <a:rPr sz="1600" b="0" i="0" dirty="0">
                 <a:solidFill>
                   <a:srgbClr val="E33B2E"/>
                 </a:solidFill>
@@ -4296,7 +4540,7 @@
         </p:nvSpPr>
         <p:spPr>
           <a:xfrm>
-            <a:off x="274320" y="3566160"/>
+            <a:off x="320040" y="4023360"/>
             <a:ext cx="11612880" cy="2286000"/>
           </a:xfrm>
           <a:prstGeom prst="rect">
@@ -4330,6 +4574,7 @@
           <a:lstStyle/>
           <a:p>
             <a:pPr algn="ctr"/>
+            <a:endParaRPr/>
           </a:p>
         </p:txBody>
       </p:sp>
@@ -4341,7 +4586,7 @@
         </p:nvSpPr>
         <p:spPr>
           <a:xfrm>
-            <a:off x="411480" y="3611880"/>
+            <a:off x="411480" y="4089400"/>
             <a:ext cx="11247120" cy="411480"/>
           </a:xfrm>
           <a:prstGeom prst="rect">
@@ -4357,12 +4602,60 @@
           <a:p>
             <a:pPr algn="l"/>
             <a:r>
-              <a:rPr sz="2000" b="1" i="0">
+              <a:rPr sz="2000" b="1" i="0" dirty="0">
                 <a:solidFill>
                   <a:srgbClr val="228844"/>
                 </a:solidFill>
               </a:rPr>
-              <a:t>Pipeline A — Direct Semantic S2S  (Baseline Comparison: SpeechTokenizer / Mimi / EnCodec)</a:t>
+              <a:t>Pipeline </a:t>
+            </a:r>
+            <a:r>
+              <a:rPr lang="en-US" sz="2000" b="1" i="0" dirty="0">
+                <a:solidFill>
+                  <a:srgbClr val="228844"/>
+                </a:solidFill>
+              </a:rPr>
+              <a:t>B</a:t>
+            </a:r>
+            <a:r>
+              <a:rPr sz="2000" b="1" i="0" dirty="0">
+                <a:solidFill>
+                  <a:srgbClr val="228844"/>
+                </a:solidFill>
+              </a:rPr>
+              <a:t> — Direct Semantic S2S  (Baseline Comparison: </a:t>
+            </a:r>
+            <a:r>
+              <a:rPr sz="2000" b="1" i="0" dirty="0" err="1">
+                <a:solidFill>
+                  <a:srgbClr val="228844"/>
+                </a:solidFill>
+              </a:rPr>
+              <a:t>SpeechTokenizer</a:t>
+            </a:r>
+            <a:r>
+              <a:rPr sz="2000" b="1" i="0" dirty="0">
+                <a:solidFill>
+                  <a:srgbClr val="228844"/>
+                </a:solidFill>
+              </a:rPr>
+              <a:t> / Mimi / </a:t>
+            </a:r>
+            <a:r>
+              <a:rPr sz="2000" b="1" i="0" dirty="0" err="1">
+                <a:solidFill>
+                  <a:srgbClr val="228844"/>
+                </a:solidFill>
+              </a:rPr>
+              <a:t>EnCodec</a:t>
+            </a:r>
+            <a:r>
+              <a:rPr sz="2000" b="1" i="0" dirty="0">
+                <a:solidFill>
+                  <a:srgbClr val="228844"/>
+                </a:solidFill>
+              </a:rPr>
+              <a:t>)</a:t>
             </a:r>
           </a:p>
         </p:txBody>
@@ -4375,7 +4668,7 @@
         </p:nvSpPr>
         <p:spPr>
           <a:xfrm>
-            <a:off x="411480" y="4041648"/>
+            <a:off x="411480" y="4553373"/>
             <a:ext cx="11247120" cy="777240"/>
           </a:xfrm>
           <a:prstGeom prst="rect">
@@ -4391,12 +4684,28 @@
           <a:p>
             <a:pPr algn="l"/>
             <a:r>
-              <a:rPr sz="1800" b="0" i="0">
+              <a:rPr sz="1800" b="0" i="0" dirty="0">
                 <a:solidFill>
                   <a:srgbClr val="000000"/>
                 </a:solidFill>
               </a:rPr>
-              <a:t>Mic Input  →  Neural Audio Tokenizer (20 ms frame)  →  Discrete Semantic Tokens  →  Wireless Channel  →  Streaming Neural Vocoder  →  Speaker Output</a:t>
+              <a:t>Mic Input  →  Neural Audio Tokenizer (20 </a:t>
+            </a:r>
+            <a:r>
+              <a:rPr sz="1800" b="0" i="0" dirty="0" err="1">
+                <a:solidFill>
+                  <a:srgbClr val="000000"/>
+                </a:solidFill>
+              </a:rPr>
+              <a:t>ms</a:t>
+            </a:r>
+            <a:r>
+              <a:rPr sz="1800" b="0" i="0" dirty="0">
+                <a:solidFill>
+                  <a:srgbClr val="000000"/>
+                </a:solidFill>
+              </a:rPr>
+              <a:t> frame)  →  Discrete Semantic Tokens  →  Wireless Channel  →  Streaming Neural Vocoder  →  Speaker Output</a:t>
             </a:r>
           </a:p>
         </p:txBody>
@@ -4409,7 +4718,7 @@
         </p:nvSpPr>
         <p:spPr>
           <a:xfrm>
-            <a:off x="411480" y="4846320"/>
+            <a:off x="411480" y="5251027"/>
             <a:ext cx="11247120" cy="411480"/>
           </a:xfrm>
           <a:prstGeom prst="rect">
@@ -4425,12 +4734,28 @@
           <a:p>
             <a:pPr algn="l"/>
             <a:r>
-              <a:rPr sz="1600" b="0" i="0">
+              <a:rPr sz="1600" b="0" i="0" dirty="0">
                 <a:solidFill>
                   <a:srgbClr val="228844"/>
                 </a:solidFill>
               </a:rPr>
-              <a:t>No buffering required: first audio out in 43–63 ms   |   Scaling: O(1) — constant regardless of duration</a:t>
+              <a:t>No buffering required: first audio out in 43–63 </a:t>
+            </a:r>
+            <a:r>
+              <a:rPr sz="1600" b="0" i="0" dirty="0" err="1">
+                <a:solidFill>
+                  <a:srgbClr val="228844"/>
+                </a:solidFill>
+              </a:rPr>
+              <a:t>ms</a:t>
+            </a:r>
+            <a:r>
+              <a:rPr sz="1600" b="0" i="0" dirty="0">
+                <a:solidFill>
+                  <a:srgbClr val="228844"/>
+                </a:solidFill>
+              </a:rPr>
+              <a:t>   |   Scaling: O(1) — constant regardless of duration</a:t>
             </a:r>
           </a:p>
         </p:txBody>
@@ -4444,7 +4769,7 @@
 </file>
 
 <file path=ppt/slides/slide4.xml><?xml version="1.0" encoding="utf-8"?>
-<p:sld xmlns:a="http://schemas.openxmlformats.org/drawingml/2006/main" xmlns:p="http://schemas.openxmlformats.org/presentationml/2006/main" xmlns:r="http://schemas.openxmlformats.org/officeDocument/2006/relationships">
+<p:sld xmlns:a="http://schemas.openxmlformats.org/drawingml/2006/main" xmlns:r="http://schemas.openxmlformats.org/officeDocument/2006/relationships" xmlns:p="http://schemas.openxmlformats.org/presentationml/2006/main">
   <p:cSld>
     <p:bg>
       <p:bgPr>
@@ -4460,7 +4785,14 @@
         <p:cNvGrpSpPr/>
         <p:nvPr/>
       </p:nvGrpSpPr>
-      <p:grpSpPr/>
+      <p:grpSpPr>
+        <a:xfrm>
+          <a:off x="0" y="0"/>
+          <a:ext cx="0" cy="0"/>
+          <a:chOff x="0" y="0"/>
+          <a:chExt cx="0" cy="0"/>
+        </a:xfrm>
+      </p:grpSpPr>
       <p:sp>
         <p:nvSpPr>
           <p:cNvPr id="2" name="Rectangle 1"/>
@@ -4501,6 +4833,7 @@
           <a:lstStyle/>
           <a:p>
             <a:pPr algn="ctr"/>
+            <a:endParaRPr/>
           </a:p>
         </p:txBody>
       </p:sp>
@@ -4566,7 +4899,7 @@
               </a:spcBef>
             </a:pPr>
             <a:r>
-              <a:rPr sz="2200" b="1">
+              <a:rPr sz="2200" b="1" dirty="0">
                 <a:solidFill>
                   <a:srgbClr val="1A376C"/>
                 </a:solidFill>
@@ -4581,7 +4914,7 @@
               </a:spcBef>
             </a:pPr>
             <a:r>
-              <a:rPr sz="2200" b="0">
+              <a:rPr sz="2200" b="0" dirty="0">
                 <a:solidFill>
                   <a:srgbClr val="000000"/>
                 </a:solidFill>
@@ -4596,7 +4929,7 @@
               </a:spcBef>
             </a:pPr>
             <a:r>
-              <a:rPr sz="2200" b="0">
+              <a:rPr sz="2200" b="0" dirty="0">
                 <a:solidFill>
                   <a:srgbClr val="000000"/>
                 </a:solidFill>
@@ -4611,7 +4944,7 @@
               </a:spcBef>
             </a:pPr>
             <a:r>
-              <a:rPr sz="2200" b="0">
+              <a:rPr sz="2200" b="0" dirty="0">
                 <a:solidFill>
                   <a:srgbClr val="000000"/>
                 </a:solidFill>
@@ -4626,7 +4959,7 @@
               </a:spcBef>
             </a:pPr>
             <a:r>
-              <a:rPr sz="2200" b="0">
+              <a:rPr sz="2200" b="0" dirty="0">
                 <a:solidFill>
                   <a:srgbClr val="000000"/>
                 </a:solidFill>
@@ -4640,6 +4973,11 @@
                 <a:spcPts val="400"/>
               </a:spcBef>
             </a:pPr>
+            <a:endParaRPr sz="2200" b="0" dirty="0">
+              <a:solidFill>
+                <a:srgbClr val="000000"/>
+              </a:solidFill>
+            </a:endParaRPr>
           </a:p>
           <a:p>
             <a:pPr algn="l">
@@ -4648,7 +4986,7 @@
               </a:spcBef>
             </a:pPr>
             <a:r>
-              <a:rPr sz="2200" b="1">
+              <a:rPr sz="2200" b="1" dirty="0">
                 <a:solidFill>
                   <a:srgbClr val="1A376C"/>
                 </a:solidFill>
@@ -4663,7 +5001,7 @@
               </a:spcBef>
             </a:pPr>
             <a:r>
-              <a:rPr sz="2200" b="0">
+              <a:rPr sz="2200" b="0" dirty="0">
                 <a:solidFill>
                   <a:srgbClr val="000000"/>
                 </a:solidFill>
@@ -4678,7 +5016,7 @@
               </a:spcBef>
             </a:pPr>
             <a:r>
-              <a:rPr sz="2200" b="0">
+              <a:rPr sz="2200" b="0" dirty="0">
                 <a:solidFill>
                   <a:srgbClr val="000000"/>
                 </a:solidFill>
@@ -4693,7 +5031,7 @@
               </a:spcBef>
             </a:pPr>
             <a:r>
-              <a:rPr sz="2200" b="0">
+              <a:rPr sz="2200" b="0" dirty="0">
                 <a:solidFill>
                   <a:srgbClr val="000000"/>
                 </a:solidFill>
@@ -4708,7 +5046,7 @@
               </a:spcBef>
             </a:pPr>
             <a:r>
-              <a:rPr sz="2200" b="0">
+              <a:rPr sz="2200" b="0" dirty="0">
                 <a:solidFill>
                   <a:srgbClr val="000000"/>
                 </a:solidFill>
@@ -4724,7 +5062,13 @@
           <p:cNvGraphicFramePr>
             <a:graphicFrameLocks noGrp="1"/>
           </p:cNvGraphicFramePr>
-          <p:nvPr/>
+          <p:nvPr>
+            <p:extLst>
+              <p:ext uri="{D42A27DB-BD31-4B8C-83A1-F6EECF244321}">
+                <p14:modId xmlns:p14="http://schemas.microsoft.com/office/powerpoint/2010/main" val="704334695"/>
+              </p:ext>
+            </p:extLst>
+          </p:nvPr>
         </p:nvGraphicFramePr>
         <p:xfrm>
           <a:off x="6035040" y="1280160"/>
@@ -4737,9 +5081,27 @@
                 <a:tableStyleId>{5C22544A-7EE6-4342-B048-85BDC9FD1C3A}</a:tableStyleId>
               </a:tblPr>
               <a:tblGrid>
-                <a:gridCol w="1981200"/>
-                <a:gridCol w="1981200"/>
-                <a:gridCol w="1981200"/>
+                <a:gridCol w="1981200">
+                  <a:extLst>
+                    <a:ext uri="{9D8B030D-6E8A-4147-A177-3AD203B41FA5}">
+                      <a16:colId xmlns:a16="http://schemas.microsoft.com/office/drawing/2014/main" val="20000"/>
+                    </a:ext>
+                  </a:extLst>
+                </a:gridCol>
+                <a:gridCol w="1981200">
+                  <a:extLst>
+                    <a:ext uri="{9D8B030D-6E8A-4147-A177-3AD203B41FA5}">
+                      <a16:colId xmlns:a16="http://schemas.microsoft.com/office/drawing/2014/main" val="20001"/>
+                    </a:ext>
+                  </a:extLst>
+                </a:gridCol>
+                <a:gridCol w="1981200">
+                  <a:extLst>
+                    <a:ext uri="{9D8B030D-6E8A-4147-A177-3AD203B41FA5}">
+                      <a16:colId xmlns:a16="http://schemas.microsoft.com/office/drawing/2014/main" val="20002"/>
+                    </a:ext>
+                  </a:extLst>
+                </a:gridCol>
               </a:tblGrid>
               <a:tr h="685800">
                 <a:tc>
@@ -4771,12 +5133,28 @@
                     <a:p>
                       <a:pPr algn="ctr"/>
                       <a:r>
-                        <a:rPr sz="1600" b="1">
+                        <a:rPr sz="1600" b="1" dirty="0">
                           <a:solidFill>
                             <a:srgbClr val="FFFFFF"/>
                           </a:solidFill>
                         </a:rPr>
-                        <a:t>Pipeline B (S2T2S)</a:t>
+                        <a:t>Pipeline </a:t>
+                      </a:r>
+                      <a:r>
+                        <a:rPr lang="en-US" sz="1600" b="1" dirty="0">
+                          <a:solidFill>
+                            <a:srgbClr val="FFFFFF"/>
+                          </a:solidFill>
+                        </a:rPr>
+                        <a:t>A</a:t>
+                      </a:r>
+                      <a:r>
+                        <a:rPr sz="1600" b="1" dirty="0">
+                          <a:solidFill>
+                            <a:srgbClr val="FFFFFF"/>
+                          </a:solidFill>
+                        </a:rPr>
+                        <a:t> (S2T2S)</a:t>
                       </a:r>
                     </a:p>
                   </a:txBody>
@@ -4793,12 +5171,28 @@
                     <a:p>
                       <a:pPr algn="ctr"/>
                       <a:r>
-                        <a:rPr sz="1600" b="1">
+                        <a:rPr sz="1600" b="1" dirty="0">
                           <a:solidFill>
                             <a:srgbClr val="FFFFFF"/>
                           </a:solidFill>
                         </a:rPr>
-                        <a:t>Pipeline A (S2S)</a:t>
+                        <a:t>Pipeline </a:t>
+                      </a:r>
+                      <a:r>
+                        <a:rPr lang="en-US" sz="1600" b="1" dirty="0">
+                          <a:solidFill>
+                            <a:srgbClr val="FFFFFF"/>
+                          </a:solidFill>
+                        </a:rPr>
+                        <a:t>B </a:t>
+                      </a:r>
+                      <a:r>
+                        <a:rPr sz="1600" b="1" dirty="0">
+                          <a:solidFill>
+                            <a:srgbClr val="FFFFFF"/>
+                          </a:solidFill>
+                        </a:rPr>
+                        <a:t>(S2S)</a:t>
                       </a:r>
                     </a:p>
                   </a:txBody>
@@ -4808,6 +5202,11 @@
                     </a:solidFill>
                   </a:tcPr>
                 </a:tc>
+                <a:extLst>
+                  <a:ext uri="{0D108BD9-81ED-4DB2-BD59-A6C34878D82A}">
+                    <a16:rowId xmlns:a16="http://schemas.microsoft.com/office/drawing/2014/main" val="10000"/>
+                  </a:ext>
+                </a:extLst>
               </a:tr>
               <a:tr h="685800">
                 <a:tc>
@@ -4876,6 +5275,11 @@
                     </a:solidFill>
                   </a:tcPr>
                 </a:tc>
+                <a:extLst>
+                  <a:ext uri="{0D108BD9-81ED-4DB2-BD59-A6C34878D82A}">
+                    <a16:rowId xmlns:a16="http://schemas.microsoft.com/office/drawing/2014/main" val="10001"/>
+                  </a:ext>
+                </a:extLst>
               </a:tr>
               <a:tr h="685800">
                 <a:tc>
@@ -4944,6 +5348,11 @@
                     </a:solidFill>
                   </a:tcPr>
                 </a:tc>
+                <a:extLst>
+                  <a:ext uri="{0D108BD9-81ED-4DB2-BD59-A6C34878D82A}">
+                    <a16:rowId xmlns:a16="http://schemas.microsoft.com/office/drawing/2014/main" val="10002"/>
+                  </a:ext>
+                </a:extLst>
               </a:tr>
               <a:tr h="685800">
                 <a:tc>
@@ -5012,6 +5421,11 @@
                     </a:solidFill>
                   </a:tcPr>
                 </a:tc>
+                <a:extLst>
+                  <a:ext uri="{0D108BD9-81ED-4DB2-BD59-A6C34878D82A}">
+                    <a16:rowId xmlns:a16="http://schemas.microsoft.com/office/drawing/2014/main" val="10003"/>
+                  </a:ext>
+                </a:extLst>
               </a:tr>
               <a:tr h="685800">
                 <a:tc>
@@ -5080,6 +5494,11 @@
                     </a:solidFill>
                   </a:tcPr>
                 </a:tc>
+                <a:extLst>
+                  <a:ext uri="{0D108BD9-81ED-4DB2-BD59-A6C34878D82A}">
+                    <a16:rowId xmlns:a16="http://schemas.microsoft.com/office/drawing/2014/main" val="10004"/>
+                  </a:ext>
+                </a:extLst>
               </a:tr>
               <a:tr h="685800">
                 <a:tc>
@@ -5133,12 +5552,28 @@
                     <a:p>
                       <a:pPr algn="ctr"/>
                       <a:r>
-                        <a:rPr sz="1500">
+                        <a:rPr sz="1500" dirty="0">
                           <a:solidFill>
                             <a:srgbClr val="000000"/>
                           </a:solidFill>
                         </a:rPr>
-                        <a:t>YES  (&lt; 200 ms)</a:t>
+                        <a:t>YES  (&lt; 200 </a:t>
+                      </a:r>
+                      <a:r>
+                        <a:rPr sz="1500" dirty="0" err="1">
+                          <a:solidFill>
+                            <a:srgbClr val="000000"/>
+                          </a:solidFill>
+                        </a:rPr>
+                        <a:t>ms</a:t>
+                      </a:r>
+                      <a:r>
+                        <a:rPr sz="1500" dirty="0">
+                          <a:solidFill>
+                            <a:srgbClr val="000000"/>
+                          </a:solidFill>
+                        </a:rPr>
+                        <a:t>)</a:t>
                       </a:r>
                     </a:p>
                   </a:txBody>
@@ -5148,6 +5583,11 @@
                     </a:solidFill>
                   </a:tcPr>
                 </a:tc>
+                <a:extLst>
+                  <a:ext uri="{0D108BD9-81ED-4DB2-BD59-A6C34878D82A}">
+                    <a16:rowId xmlns:a16="http://schemas.microsoft.com/office/drawing/2014/main" val="10005"/>
+                  </a:ext>
+                </a:extLst>
               </a:tr>
             </a:tbl>
           </a:graphicData>
@@ -5196,7 +5636,7 @@
 </file>
 
 <file path=ppt/slides/slide5.xml><?xml version="1.0" encoding="utf-8"?>
-<p:sld xmlns:a="http://schemas.openxmlformats.org/drawingml/2006/main" xmlns:p="http://schemas.openxmlformats.org/presentationml/2006/main" xmlns:r="http://schemas.openxmlformats.org/officeDocument/2006/relationships">
+<p:sld xmlns:a="http://schemas.openxmlformats.org/drawingml/2006/main" xmlns:r="http://schemas.openxmlformats.org/officeDocument/2006/relationships" xmlns:p="http://schemas.openxmlformats.org/presentationml/2006/main">
   <p:cSld>
     <p:bg>
       <p:bgPr>
@@ -5212,7 +5652,14 @@
         <p:cNvGrpSpPr/>
         <p:nvPr/>
       </p:nvGrpSpPr>
-      <p:grpSpPr/>
+      <p:grpSpPr>
+        <a:xfrm>
+          <a:off x="0" y="0"/>
+          <a:ext cx="0" cy="0"/>
+          <a:chOff x="0" y="0"/>
+          <a:chExt cx="0" cy="0"/>
+        </a:xfrm>
+      </p:grpSpPr>
       <p:sp>
         <p:nvSpPr>
           <p:cNvPr id="2" name="Rectangle 1"/>
@@ -5253,6 +5700,7 @@
           <a:lstStyle/>
           <a:p>
             <a:pPr algn="ctr"/>
+            <a:endParaRPr/>
           </a:p>
         </p:txBody>
       </p:sp>
@@ -5306,8 +5754,8 @@
         </p:blipFill>
         <p:spPr>
           <a:xfrm>
-            <a:off x="274320" y="1143000"/>
-            <a:ext cx="5943600" cy="4389120"/>
+            <a:off x="274320" y="1142999"/>
+            <a:ext cx="6177280" cy="4690533"/>
           </a:xfrm>
           <a:prstGeom prst="rect">
             <a:avLst/>
@@ -5322,8 +5770,8 @@
         </p:nvSpPr>
         <p:spPr>
           <a:xfrm>
-            <a:off x="6492240" y="1188720"/>
-            <a:ext cx="5394960" cy="5212080"/>
+            <a:off x="6849532" y="1188720"/>
+            <a:ext cx="5037667" cy="5273238"/>
           </a:xfrm>
           <a:prstGeom prst="rect">
             <a:avLst/>
@@ -5342,7 +5790,7 @@
               </a:spcBef>
             </a:pPr>
             <a:r>
-              <a:rPr sz="2300" b="1">
+              <a:rPr b="1" dirty="0">
                 <a:solidFill>
                   <a:srgbClr val="1A376C"/>
                 </a:solidFill>
@@ -5357,7 +5805,7 @@
               </a:spcBef>
             </a:pPr>
             <a:r>
-              <a:rPr sz="2200" b="0">
+              <a:rPr b="0" dirty="0">
                 <a:solidFill>
                   <a:srgbClr val="000000"/>
                 </a:solidFill>
@@ -5372,7 +5820,7 @@
               </a:spcBef>
             </a:pPr>
             <a:r>
-              <a:rPr sz="2200" b="0">
+              <a:rPr b="0" dirty="0">
                 <a:solidFill>
                   <a:srgbClr val="000000"/>
                 </a:solidFill>
@@ -5387,7 +5835,7 @@
               </a:spcBef>
             </a:pPr>
             <a:r>
-              <a:rPr sz="2200" b="0">
+              <a:rPr b="0" dirty="0">
                 <a:solidFill>
                   <a:srgbClr val="000000"/>
                 </a:solidFill>
@@ -5401,6 +5849,11 @@
                 <a:spcPts val="400"/>
               </a:spcBef>
             </a:pPr>
+            <a:endParaRPr b="0" dirty="0">
+              <a:solidFill>
+                <a:srgbClr val="000000"/>
+              </a:solidFill>
+            </a:endParaRPr>
           </a:p>
           <a:p>
             <a:pPr algn="l">
@@ -5409,7 +5862,7 @@
               </a:spcBef>
             </a:pPr>
             <a:r>
-              <a:rPr sz="2300" b="1">
+              <a:rPr b="1" dirty="0">
                 <a:solidFill>
                   <a:srgbClr val="1A376C"/>
                 </a:solidFill>
@@ -5424,7 +5877,7 @@
               </a:spcBef>
             </a:pPr>
             <a:r>
-              <a:rPr sz="2200" b="0">
+              <a:rPr b="0" dirty="0">
                 <a:solidFill>
                   <a:srgbClr val="000000"/>
                 </a:solidFill>
@@ -5439,7 +5892,7 @@
               </a:spcBef>
             </a:pPr>
             <a:r>
-              <a:rPr sz="2100" b="0">
+              <a:rPr b="0" dirty="0">
                 <a:solidFill>
                   <a:srgbClr val="000000"/>
                 </a:solidFill>
@@ -5454,7 +5907,7 @@
               </a:spcBef>
             </a:pPr>
             <a:r>
-              <a:rPr sz="2200" b="0">
+              <a:rPr b="0" dirty="0">
                 <a:solidFill>
                   <a:srgbClr val="000000"/>
                 </a:solidFill>
@@ -5469,7 +5922,7 @@
               </a:spcBef>
             </a:pPr>
             <a:r>
-              <a:rPr sz="2100" b="0">
+              <a:rPr b="0" dirty="0">
                 <a:solidFill>
                   <a:srgbClr val="000000"/>
                 </a:solidFill>
@@ -5483,6 +5936,11 @@
                 <a:spcPts val="400"/>
               </a:spcBef>
             </a:pPr>
+            <a:endParaRPr b="0" dirty="0">
+              <a:solidFill>
+                <a:srgbClr val="000000"/>
+              </a:solidFill>
+            </a:endParaRPr>
           </a:p>
           <a:p>
             <a:pPr algn="l">
@@ -5491,7 +5949,7 @@
               </a:spcBef>
             </a:pPr>
             <a:r>
-              <a:rPr sz="2300" b="1">
+              <a:rPr b="1" dirty="0">
                 <a:solidFill>
                   <a:srgbClr val="1A376C"/>
                 </a:solidFill>
@@ -5506,7 +5964,7 @@
               </a:spcBef>
             </a:pPr>
             <a:r>
-              <a:rPr sz="2200" b="0">
+              <a:rPr b="0" dirty="0">
                 <a:solidFill>
                   <a:srgbClr val="000000"/>
                 </a:solidFill>
@@ -5521,7 +5979,7 @@
               </a:spcBef>
             </a:pPr>
             <a:r>
-              <a:rPr sz="2100" b="0">
+              <a:rPr b="0" dirty="0">
                 <a:solidFill>
                   <a:srgbClr val="000000"/>
                 </a:solidFill>
@@ -5536,7 +5994,7 @@
               </a:spcBef>
             </a:pPr>
             <a:r>
-              <a:rPr sz="2200" b="0">
+              <a:rPr b="0" dirty="0">
                 <a:solidFill>
                   <a:srgbClr val="000000"/>
                 </a:solidFill>
@@ -5555,7 +6013,7 @@
 </file>
 
 <file path=ppt/slides/slide6.xml><?xml version="1.0" encoding="utf-8"?>
-<p:sld xmlns:a="http://schemas.openxmlformats.org/drawingml/2006/main" xmlns:p="http://schemas.openxmlformats.org/presentationml/2006/main" xmlns:r="http://schemas.openxmlformats.org/officeDocument/2006/relationships">
+<p:sld xmlns:a="http://schemas.openxmlformats.org/drawingml/2006/main" xmlns:r="http://schemas.openxmlformats.org/officeDocument/2006/relationships" xmlns:p="http://schemas.openxmlformats.org/presentationml/2006/main">
   <p:cSld>
     <p:bg>
       <p:bgPr>
@@ -5571,7 +6029,14 @@
         <p:cNvGrpSpPr/>
         <p:nvPr/>
       </p:nvGrpSpPr>
-      <p:grpSpPr/>
+      <p:grpSpPr>
+        <a:xfrm>
+          <a:off x="0" y="0"/>
+          <a:ext cx="0" cy="0"/>
+          <a:chOff x="0" y="0"/>
+          <a:chExt cx="0" cy="0"/>
+        </a:xfrm>
+      </p:grpSpPr>
       <p:sp>
         <p:nvSpPr>
           <p:cNvPr id="2" name="Rectangle 1"/>
@@ -5612,6 +6077,7 @@
           <a:lstStyle/>
           <a:p>
             <a:pPr algn="ctr"/>
+            <a:endParaRPr/>
           </a:p>
         </p:txBody>
       </p:sp>
@@ -5677,7 +6143,7 @@
               </a:spcBef>
             </a:pPr>
             <a:r>
-              <a:rPr sz="2300" b="1">
+              <a:rPr sz="2300" b="1" dirty="0">
                 <a:solidFill>
                   <a:srgbClr val="1A376C"/>
                 </a:solidFill>
@@ -5692,13 +6158,26 @@
               </a:spcBef>
             </a:pPr>
             <a:r>
-              <a:rPr sz="2200" b="0">
+              <a:rPr sz="2200" b="0" dirty="0">
                 <a:solidFill>
                   <a:srgbClr val="000000"/>
                 </a:solidFill>
               </a:rPr>
-              <a:t>• S2S (Mimi):             43 ms</a:t>
-            </a:r>
+              <a:t>• S2S (Mimi):             43 </a:t>
+            </a:r>
+            <a:r>
+              <a:rPr sz="2200" b="0" dirty="0" err="1">
+                <a:solidFill>
+                  <a:srgbClr val="000000"/>
+                </a:solidFill>
+              </a:rPr>
+              <a:t>ms</a:t>
+            </a:r>
+            <a:endParaRPr sz="2200" b="0" dirty="0">
+              <a:solidFill>
+                <a:srgbClr val="000000"/>
+              </a:solidFill>
+            </a:endParaRPr>
           </a:p>
           <a:p>
             <a:pPr algn="l">
@@ -5707,13 +6186,42 @@
               </a:spcBef>
             </a:pPr>
             <a:r>
-              <a:rPr sz="2200" b="0">
+              <a:rPr sz="2200" b="0" dirty="0">
                 <a:solidFill>
                   <a:srgbClr val="000000"/>
                 </a:solidFill>
               </a:rPr>
-              <a:t>• S2S (SpeechTokenizer):  63 ms</a:t>
-            </a:r>
+              <a:t>• S2S (</a:t>
+            </a:r>
+            <a:r>
+              <a:rPr sz="2200" b="0" dirty="0" err="1">
+                <a:solidFill>
+                  <a:srgbClr val="000000"/>
+                </a:solidFill>
+              </a:rPr>
+              <a:t>SpeechTokenizer</a:t>
+            </a:r>
+            <a:r>
+              <a:rPr sz="2200" b="0" dirty="0">
+                <a:solidFill>
+                  <a:srgbClr val="000000"/>
+                </a:solidFill>
+              </a:rPr>
+              <a:t>):  63 </a:t>
+            </a:r>
+            <a:r>
+              <a:rPr sz="2200" b="0" dirty="0" err="1">
+                <a:solidFill>
+                  <a:srgbClr val="000000"/>
+                </a:solidFill>
+              </a:rPr>
+              <a:t>ms</a:t>
+            </a:r>
+            <a:endParaRPr sz="2200" b="0" dirty="0">
+              <a:solidFill>
+                <a:srgbClr val="000000"/>
+              </a:solidFill>
+            </a:endParaRPr>
           </a:p>
           <a:p>
             <a:pPr algn="l">
@@ -5722,13 +6230,26 @@
               </a:spcBef>
             </a:pPr>
             <a:r>
-              <a:rPr sz="2200" b="0">
+              <a:rPr sz="2200" b="0" dirty="0">
                 <a:solidFill>
                   <a:srgbClr val="000000"/>
                 </a:solidFill>
               </a:rPr>
-              <a:t>• S2T2S — Short audio:  5,278 ms</a:t>
-            </a:r>
+              <a:t>• S2T2S — Short audio:  5,278 </a:t>
+            </a:r>
+            <a:r>
+              <a:rPr sz="2200" b="0" dirty="0" err="1">
+                <a:solidFill>
+                  <a:srgbClr val="000000"/>
+                </a:solidFill>
+              </a:rPr>
+              <a:t>ms</a:t>
+            </a:r>
+            <a:endParaRPr sz="2200" b="0" dirty="0">
+              <a:solidFill>
+                <a:srgbClr val="000000"/>
+              </a:solidFill>
+            </a:endParaRPr>
           </a:p>
           <a:p>
             <a:pPr algn="l">
@@ -5737,13 +6258,26 @@
               </a:spcBef>
             </a:pPr>
             <a:r>
-              <a:rPr sz="2200" b="0">
+              <a:rPr sz="2200" b="0" dirty="0">
                 <a:solidFill>
                   <a:srgbClr val="000000"/>
                 </a:solidFill>
               </a:rPr>
-              <a:t>• S2T2S — Long audio:  29,169 ms</a:t>
-            </a:r>
+              <a:t>• S2T2S — Long audio:  29,169 </a:t>
+            </a:r>
+            <a:r>
+              <a:rPr sz="2200" b="0" dirty="0" err="1">
+                <a:solidFill>
+                  <a:srgbClr val="000000"/>
+                </a:solidFill>
+              </a:rPr>
+              <a:t>ms</a:t>
+            </a:r>
+            <a:endParaRPr sz="2200" b="0" dirty="0">
+              <a:solidFill>
+                <a:srgbClr val="000000"/>
+              </a:solidFill>
+            </a:endParaRPr>
           </a:p>
           <a:p>
             <a:pPr>
@@ -5751,6 +6285,11 @@
                 <a:spcPts val="400"/>
               </a:spcBef>
             </a:pPr>
+            <a:endParaRPr sz="2200" b="0" dirty="0">
+              <a:solidFill>
+                <a:srgbClr val="000000"/>
+              </a:solidFill>
+            </a:endParaRPr>
           </a:p>
           <a:p>
             <a:pPr algn="l">
@@ -5759,7 +6298,7 @@
               </a:spcBef>
             </a:pPr>
             <a:r>
-              <a:rPr sz="2300" b="1">
+              <a:rPr sz="2300" b="1" dirty="0">
                 <a:solidFill>
                   <a:srgbClr val="1A376C"/>
                 </a:solidFill>
@@ -5773,6 +6312,11 @@
                 <a:spcPts val="400"/>
               </a:spcBef>
             </a:pPr>
+            <a:endParaRPr sz="2300" b="1" dirty="0">
+              <a:solidFill>
+                <a:srgbClr val="1A376C"/>
+              </a:solidFill>
+            </a:endParaRPr>
           </a:p>
           <a:p>
             <a:pPr algn="l">
@@ -5781,7 +6325,7 @@
               </a:spcBef>
             </a:pPr>
             <a:r>
-              <a:rPr sz="2300" b="1">
+              <a:rPr sz="2300" b="1" dirty="0">
                 <a:solidFill>
                   <a:srgbClr val="1A376C"/>
                 </a:solidFill>
@@ -5796,7 +6340,7 @@
               </a:spcBef>
             </a:pPr>
             <a:r>
-              <a:rPr sz="2200" b="0">
+              <a:rPr sz="2200" b="0" dirty="0">
                 <a:solidFill>
                   <a:srgbClr val="000000"/>
                 </a:solidFill>
@@ -5811,7 +6355,7 @@
               </a:spcBef>
             </a:pPr>
             <a:r>
-              <a:rPr sz="2100" b="0">
+              <a:rPr sz="2100" b="0" dirty="0">
                 <a:solidFill>
                   <a:srgbClr val="000000"/>
                 </a:solidFill>
@@ -5826,7 +6370,7 @@
               </a:spcBef>
             </a:pPr>
             <a:r>
-              <a:rPr sz="2200" b="0">
+              <a:rPr sz="2200" b="0" dirty="0">
                 <a:solidFill>
                   <a:srgbClr val="000000"/>
                 </a:solidFill>
@@ -5841,7 +6385,7 @@
               </a:spcBef>
             </a:pPr>
             <a:r>
-              <a:rPr sz="2200" b="0">
+              <a:rPr sz="2200" b="0" dirty="0">
                 <a:solidFill>
                   <a:srgbClr val="000000"/>
                 </a:solidFill>
@@ -5855,6 +6399,11 @@
                 <a:spcPts val="400"/>
               </a:spcBef>
             </a:pPr>
+            <a:endParaRPr sz="2200" b="0" dirty="0">
+              <a:solidFill>
+                <a:srgbClr val="000000"/>
+              </a:solidFill>
+            </a:endParaRPr>
           </a:p>
           <a:p>
             <a:pPr algn="l">
@@ -5863,13 +6412,26 @@
               </a:spcBef>
             </a:pPr>
             <a:r>
-              <a:rPr sz="2300" b="1">
+              <a:rPr sz="2300" b="1" dirty="0">
                 <a:solidFill>
                   <a:srgbClr val="1A376C"/>
                 </a:solidFill>
               </a:rPr>
-              <a:t>ITU-T G.114 Threshold = 200 ms</a:t>
-            </a:r>
+              <a:t>ITU-T G.114 Threshold = 200 </a:t>
+            </a:r>
+            <a:r>
+              <a:rPr sz="2300" b="1" dirty="0" err="1">
+                <a:solidFill>
+                  <a:srgbClr val="1A376C"/>
+                </a:solidFill>
+              </a:rPr>
+              <a:t>ms</a:t>
+            </a:r>
+            <a:endParaRPr sz="2300" b="1" dirty="0">
+              <a:solidFill>
+                <a:srgbClr val="1A376C"/>
+              </a:solidFill>
+            </a:endParaRPr>
           </a:p>
           <a:p>
             <a:pPr algn="l">
@@ -5878,12 +6440,28 @@
               </a:spcBef>
             </a:pPr>
             <a:r>
-              <a:rPr sz="2200" b="0">
+              <a:rPr sz="2200" b="0" dirty="0">
                 <a:solidFill>
                   <a:srgbClr val="000000"/>
                 </a:solidFill>
               </a:rPr>
-              <a:t>• S2S: PASSES (43–63 ms)</a:t>
+              <a:t>• S2S: PASSES (43–63 </a:t>
+            </a:r>
+            <a:r>
+              <a:rPr sz="2200" b="0" dirty="0" err="1">
+                <a:solidFill>
+                  <a:srgbClr val="000000"/>
+                </a:solidFill>
+              </a:rPr>
+              <a:t>ms</a:t>
+            </a:r>
+            <a:r>
+              <a:rPr sz="2200" b="0" dirty="0">
+                <a:solidFill>
+                  <a:srgbClr val="000000"/>
+                </a:solidFill>
+              </a:rPr>
+              <a:t>)</a:t>
             </a:r>
           </a:p>
           <a:p>
@@ -5893,7 +6471,7 @@
               </a:spcBef>
             </a:pPr>
             <a:r>
-              <a:rPr sz="2200" b="0">
+              <a:rPr sz="2200" b="0" dirty="0">
                 <a:solidFill>
                   <a:srgbClr val="000000"/>
                 </a:solidFill>
@@ -5936,7 +6514,7 @@
 </file>
 
 <file path=ppt/slides/slide7.xml><?xml version="1.0" encoding="utf-8"?>
-<p:sld xmlns:a="http://schemas.openxmlformats.org/drawingml/2006/main" xmlns:p="http://schemas.openxmlformats.org/presentationml/2006/main" xmlns:r="http://schemas.openxmlformats.org/officeDocument/2006/relationships">
+<p:sld xmlns:a="http://schemas.openxmlformats.org/drawingml/2006/main" xmlns:r="http://schemas.openxmlformats.org/officeDocument/2006/relationships" xmlns:p="http://schemas.openxmlformats.org/presentationml/2006/main">
   <p:cSld>
     <p:bg>
       <p:bgPr>
@@ -5952,7 +6530,14 @@
         <p:cNvGrpSpPr/>
         <p:nvPr/>
       </p:nvGrpSpPr>
-      <p:grpSpPr/>
+      <p:grpSpPr>
+        <a:xfrm>
+          <a:off x="0" y="0"/>
+          <a:ext cx="0" cy="0"/>
+          <a:chOff x="0" y="0"/>
+          <a:chExt cx="0" cy="0"/>
+        </a:xfrm>
+      </p:grpSpPr>
       <p:sp>
         <p:nvSpPr>
           <p:cNvPr id="2" name="Rectangle 1"/>
@@ -5993,6 +6578,7 @@
           <a:lstStyle/>
           <a:p>
             <a:pPr algn="ctr"/>
+            <a:endParaRPr/>
           </a:p>
         </p:txBody>
       </p:sp>
@@ -6064,7 +6650,7 @@
         </p:nvGraphicFramePr>
         <p:xfrm>
           <a:off x="7406640" y="1280160"/>
-          <a:ext cx="4572000" cy="3474720"/>
+          <a:ext cx="4572000" cy="3547872"/>
         </p:xfrm>
         <a:graphic>
           <a:graphicData uri="http://schemas.openxmlformats.org/drawingml/2006/table">
@@ -6073,9 +6659,27 @@
                 <a:tableStyleId>{5C22544A-7EE6-4342-B048-85BDC9FD1C3A}</a:tableStyleId>
               </a:tblPr>
               <a:tblGrid>
-                <a:gridCol w="1524000"/>
-                <a:gridCol w="1524000"/>
-                <a:gridCol w="1524000"/>
+                <a:gridCol w="1524000">
+                  <a:extLst>
+                    <a:ext uri="{9D8B030D-6E8A-4147-A177-3AD203B41FA5}">
+                      <a16:colId xmlns:a16="http://schemas.microsoft.com/office/drawing/2014/main" val="20000"/>
+                    </a:ext>
+                  </a:extLst>
+                </a:gridCol>
+                <a:gridCol w="1524000">
+                  <a:extLst>
+                    <a:ext uri="{9D8B030D-6E8A-4147-A177-3AD203B41FA5}">
+                      <a16:colId xmlns:a16="http://schemas.microsoft.com/office/drawing/2014/main" val="20001"/>
+                    </a:ext>
+                  </a:extLst>
+                </a:gridCol>
+                <a:gridCol w="1524000">
+                  <a:extLst>
+                    <a:ext uri="{9D8B030D-6E8A-4147-A177-3AD203B41FA5}">
+                      <a16:colId xmlns:a16="http://schemas.microsoft.com/office/drawing/2014/main" val="20002"/>
+                    </a:ext>
+                  </a:extLst>
+                </a:gridCol>
               </a:tblGrid>
               <a:tr h="694944">
                 <a:tc>
@@ -6144,6 +6748,11 @@
                     </a:solidFill>
                   </a:tcPr>
                 </a:tc>
+                <a:extLst>
+                  <a:ext uri="{0D108BD9-81ED-4DB2-BD59-A6C34878D82A}">
+                    <a16:rowId xmlns:a16="http://schemas.microsoft.com/office/drawing/2014/main" val="10000"/>
+                  </a:ext>
+                </a:extLst>
               </a:tr>
               <a:tr h="694944">
                 <a:tc>
@@ -6214,6 +6823,11 @@
                     </a:solidFill>
                   </a:tcPr>
                 </a:tc>
+                <a:extLst>
+                  <a:ext uri="{0D108BD9-81ED-4DB2-BD59-A6C34878D82A}">
+                    <a16:rowId xmlns:a16="http://schemas.microsoft.com/office/drawing/2014/main" val="10001"/>
+                  </a:ext>
+                </a:extLst>
               </a:tr>
               <a:tr h="694944">
                 <a:tc>
@@ -6223,7 +6837,7 @@
                     <a:p>
                       <a:pPr algn="ctr"/>
                       <a:r>
-                        <a:rPr sz="1400">
+                        <a:rPr sz="1400" dirty="0">
                           <a:solidFill>
                             <a:srgbClr val="000000"/>
                           </a:solidFill>
@@ -6268,7 +6882,7 @@
                     <a:p>
                       <a:pPr algn="ctr"/>
                       <a:r>
-                        <a:rPr sz="1400">
+                        <a:rPr sz="1400" dirty="0">
                           <a:solidFill>
                             <a:srgbClr val="000000"/>
                           </a:solidFill>
@@ -6284,6 +6898,11 @@
                     </a:solidFill>
                   </a:tcPr>
                 </a:tc>
+                <a:extLst>
+                  <a:ext uri="{0D108BD9-81ED-4DB2-BD59-A6C34878D82A}">
+                    <a16:rowId xmlns:a16="http://schemas.microsoft.com/office/drawing/2014/main" val="10002"/>
+                  </a:ext>
+                </a:extLst>
               </a:tr>
               <a:tr h="694944">
                 <a:tc>
@@ -6354,6 +6973,11 @@
                     </a:solidFill>
                   </a:tcPr>
                 </a:tc>
+                <a:extLst>
+                  <a:ext uri="{0D108BD9-81ED-4DB2-BD59-A6C34878D82A}">
+                    <a16:rowId xmlns:a16="http://schemas.microsoft.com/office/drawing/2014/main" val="10003"/>
+                  </a:ext>
+                </a:extLst>
               </a:tr>
               <a:tr h="694944">
                 <a:tc>
@@ -6408,7 +7032,7 @@
                     <a:p>
                       <a:pPr algn="ctr"/>
                       <a:r>
-                        <a:rPr sz="1400">
+                        <a:rPr sz="1400" dirty="0">
                           <a:solidFill>
                             <a:srgbClr val="000000"/>
                           </a:solidFill>
@@ -6424,6 +7048,11 @@
                     </a:solidFill>
                   </a:tcPr>
                 </a:tc>
+                <a:extLst>
+                  <a:ext uri="{0D108BD9-81ED-4DB2-BD59-A6C34878D82A}">
+                    <a16:rowId xmlns:a16="http://schemas.microsoft.com/office/drawing/2014/main" val="10004"/>
+                  </a:ext>
+                </a:extLst>
               </a:tr>
             </a:tbl>
           </a:graphicData>
@@ -6437,7 +7066,7 @@
         </p:nvSpPr>
         <p:spPr>
           <a:xfrm>
-            <a:off x="7406640" y="4892040"/>
+            <a:off x="7406640" y="5056632"/>
             <a:ext cx="4572000" cy="1371600"/>
           </a:xfrm>
           <a:prstGeom prst="rect">
@@ -6453,7 +7082,7 @@
           <a:p>
             <a:pPr algn="l"/>
             <a:r>
-              <a:rPr sz="1600" b="0" i="0">
+              <a:rPr sz="1600" b="0" i="0" dirty="0">
                 <a:solidFill>
                   <a:srgbClr val="1A376C"/>
                 </a:solidFill>
@@ -6474,7 +7103,7 @@
 </file>
 
 <file path=ppt/slides/slide8.xml><?xml version="1.0" encoding="utf-8"?>
-<p:sld xmlns:a="http://schemas.openxmlformats.org/drawingml/2006/main" xmlns:p="http://schemas.openxmlformats.org/presentationml/2006/main" xmlns:r="http://schemas.openxmlformats.org/officeDocument/2006/relationships">
+<p:sld xmlns:a="http://schemas.openxmlformats.org/drawingml/2006/main" xmlns:r="http://schemas.openxmlformats.org/officeDocument/2006/relationships" xmlns:p="http://schemas.openxmlformats.org/presentationml/2006/main">
   <p:cSld>
     <p:bg>
       <p:bgPr>
@@ -6490,7 +7119,14 @@
         <p:cNvGrpSpPr/>
         <p:nvPr/>
       </p:nvGrpSpPr>
-      <p:grpSpPr/>
+      <p:grpSpPr>
+        <a:xfrm>
+          <a:off x="0" y="0"/>
+          <a:ext cx="0" cy="0"/>
+          <a:chOff x="0" y="0"/>
+          <a:chExt cx="0" cy="0"/>
+        </a:xfrm>
+      </p:grpSpPr>
       <p:sp>
         <p:nvSpPr>
           <p:cNvPr id="2" name="Rectangle 1"/>
@@ -6531,6 +7167,7 @@
           <a:lstStyle/>
           <a:p>
             <a:pPr algn="ctr"/>
+            <a:endParaRPr/>
           </a:p>
         </p:txBody>
       </p:sp>
@@ -6587,10 +7224,34 @@
                 <a:tableStyleId>{5C22544A-7EE6-4342-B048-85BDC9FD1C3A}</a:tableStyleId>
               </a:tblPr>
               <a:tblGrid>
-                <a:gridCol w="2903220"/>
-                <a:gridCol w="2903220"/>
-                <a:gridCol w="2903220"/>
-                <a:gridCol w="2903220"/>
+                <a:gridCol w="2903220">
+                  <a:extLst>
+                    <a:ext uri="{9D8B030D-6E8A-4147-A177-3AD203B41FA5}">
+                      <a16:colId xmlns:a16="http://schemas.microsoft.com/office/drawing/2014/main" val="20000"/>
+                    </a:ext>
+                  </a:extLst>
+                </a:gridCol>
+                <a:gridCol w="2903220">
+                  <a:extLst>
+                    <a:ext uri="{9D8B030D-6E8A-4147-A177-3AD203B41FA5}">
+                      <a16:colId xmlns:a16="http://schemas.microsoft.com/office/drawing/2014/main" val="20001"/>
+                    </a:ext>
+                  </a:extLst>
+                </a:gridCol>
+                <a:gridCol w="2903220">
+                  <a:extLst>
+                    <a:ext uri="{9D8B030D-6E8A-4147-A177-3AD203B41FA5}">
+                      <a16:colId xmlns:a16="http://schemas.microsoft.com/office/drawing/2014/main" val="20002"/>
+                    </a:ext>
+                  </a:extLst>
+                </a:gridCol>
+                <a:gridCol w="2903220">
+                  <a:extLst>
+                    <a:ext uri="{9D8B030D-6E8A-4147-A177-3AD203B41FA5}">
+                      <a16:colId xmlns:a16="http://schemas.microsoft.com/office/drawing/2014/main" val="20003"/>
+                    </a:ext>
+                  </a:extLst>
+                </a:gridCol>
               </a:tblGrid>
               <a:tr h="731520">
                 <a:tc>
@@ -6681,6 +7342,11 @@
                     </a:solidFill>
                   </a:tcPr>
                 </a:tc>
+                <a:extLst>
+                  <a:ext uri="{0D108BD9-81ED-4DB2-BD59-A6C34878D82A}">
+                    <a16:rowId xmlns:a16="http://schemas.microsoft.com/office/drawing/2014/main" val="10000"/>
+                  </a:ext>
+                </a:extLst>
               </a:tr>
               <a:tr h="731520">
                 <a:tc>
@@ -6712,12 +7378,36 @@
                     <a:p>
                       <a:pPr algn="ctr"/>
                       <a:r>
-                        <a:rPr sz="1500">
+                        <a:rPr sz="1500" dirty="0" err="1">
                           <a:solidFill>
                             <a:srgbClr val="000000"/>
                           </a:solidFill>
                         </a:rPr>
-                        <a:t>FunASR SenseVoice-Small</a:t>
+                        <a:t>FunASR</a:t>
+                      </a:r>
+                      <a:r>
+                        <a:rPr sz="1500" dirty="0">
+                          <a:solidFill>
+                            <a:srgbClr val="000000"/>
+                          </a:solidFill>
+                        </a:rPr>
+                        <a:t> </a:t>
+                      </a:r>
+                      <a:r>
+                        <a:rPr sz="1500" dirty="0" err="1">
+                          <a:solidFill>
+                            <a:srgbClr val="000000"/>
+                          </a:solidFill>
+                        </a:rPr>
+                        <a:t>SenseVoice</a:t>
+                      </a:r>
+                      <a:r>
+                        <a:rPr sz="1500" dirty="0">
+                          <a:solidFill>
+                            <a:srgbClr val="000000"/>
+                          </a:solidFill>
+                        </a:rPr>
+                        <a:t>-Small</a:t>
                       </a:r>
                     </a:p>
                   </a:txBody>
@@ -6773,6 +7463,11 @@
                     </a:solidFill>
                   </a:tcPr>
                 </a:tc>
+                <a:extLst>
+                  <a:ext uri="{0D108BD9-81ED-4DB2-BD59-A6C34878D82A}">
+                    <a16:rowId xmlns:a16="http://schemas.microsoft.com/office/drawing/2014/main" val="10001"/>
+                  </a:ext>
+                </a:extLst>
               </a:tr>
               <a:tr h="731520">
                 <a:tc>
@@ -6865,6 +7560,11 @@
                     </a:solidFill>
                   </a:tcPr>
                 </a:tc>
+                <a:extLst>
+                  <a:ext uri="{0D108BD9-81ED-4DB2-BD59-A6C34878D82A}">
+                    <a16:rowId xmlns:a16="http://schemas.microsoft.com/office/drawing/2014/main" val="10002"/>
+                  </a:ext>
+                </a:extLst>
               </a:tr>
               <a:tr h="731520">
                 <a:tc>
@@ -6958,6 +7658,11 @@
                     </a:solidFill>
                   </a:tcPr>
                 </a:tc>
+                <a:extLst>
+                  <a:ext uri="{0D108BD9-81ED-4DB2-BD59-A6C34878D82A}">
+                    <a16:rowId xmlns:a16="http://schemas.microsoft.com/office/drawing/2014/main" val="10003"/>
+                  </a:ext>
+                </a:extLst>
               </a:tr>
               <a:tr h="731520">
                 <a:tc>
@@ -7050,6 +7755,11 @@
                     </a:solidFill>
                   </a:tcPr>
                 </a:tc>
+                <a:extLst>
+                  <a:ext uri="{0D108BD9-81ED-4DB2-BD59-A6C34878D82A}">
+                    <a16:rowId xmlns:a16="http://schemas.microsoft.com/office/drawing/2014/main" val="10004"/>
+                  </a:ext>
+                </a:extLst>
               </a:tr>
               <a:tr h="731520">
                 <a:tc>
@@ -7143,6 +7853,11 @@
                     </a:solidFill>
                   </a:tcPr>
                 </a:tc>
+                <a:extLst>
+                  <a:ext uri="{0D108BD9-81ED-4DB2-BD59-A6C34878D82A}">
+                    <a16:rowId xmlns:a16="http://schemas.microsoft.com/office/drawing/2014/main" val="10005"/>
+                  </a:ext>
+                </a:extLst>
               </a:tr>
               <a:tr h="731520">
                 <a:tc>
@@ -7219,7 +7934,7 @@
                     <a:p>
                       <a:pPr algn="ctr"/>
                       <a:r>
-                        <a:rPr sz="1500">
+                        <a:rPr sz="1500" dirty="0">
                           <a:solidFill>
                             <a:srgbClr val="000000"/>
                           </a:solidFill>
@@ -7235,6 +7950,11 @@
                     </a:solidFill>
                   </a:tcPr>
                 </a:tc>
+                <a:extLst>
+                  <a:ext uri="{0D108BD9-81ED-4DB2-BD59-A6C34878D82A}">
+                    <a16:rowId xmlns:a16="http://schemas.microsoft.com/office/drawing/2014/main" val="10006"/>
+                  </a:ext>
+                </a:extLst>
               </a:tr>
             </a:tbl>
           </a:graphicData>
@@ -7249,7 +7969,7 @@
 </file>
 
 <file path=ppt/slides/slide9.xml><?xml version="1.0" encoding="utf-8"?>
-<p:sld xmlns:a="http://schemas.openxmlformats.org/drawingml/2006/main" xmlns:p="http://schemas.openxmlformats.org/presentationml/2006/main" xmlns:r="http://schemas.openxmlformats.org/officeDocument/2006/relationships">
+<p:sld xmlns:a="http://schemas.openxmlformats.org/drawingml/2006/main" xmlns:r="http://schemas.openxmlformats.org/officeDocument/2006/relationships" xmlns:p="http://schemas.openxmlformats.org/presentationml/2006/main">
   <p:cSld>
     <p:bg>
       <p:bgPr>
@@ -7265,7 +7985,14 @@
         <p:cNvGrpSpPr/>
         <p:nvPr/>
       </p:nvGrpSpPr>
-      <p:grpSpPr/>
+      <p:grpSpPr>
+        <a:xfrm>
+          <a:off x="0" y="0"/>
+          <a:ext cx="0" cy="0"/>
+          <a:chOff x="0" y="0"/>
+          <a:chExt cx="0" cy="0"/>
+        </a:xfrm>
+      </p:grpSpPr>
       <p:sp>
         <p:nvSpPr>
           <p:cNvPr id="2" name="Rectangle 1"/>
@@ -7306,6 +8033,7 @@
           <a:lstStyle/>
           <a:p>
             <a:pPr algn="ctr"/>
+            <a:endParaRPr/>
           </a:p>
         </p:txBody>
       </p:sp>
@@ -7362,10 +8090,34 @@
                 <a:tableStyleId>{5C22544A-7EE6-4342-B048-85BDC9FD1C3A}</a:tableStyleId>
               </a:tblPr>
               <a:tblGrid>
-                <a:gridCol w="2903220"/>
-                <a:gridCol w="2903220"/>
-                <a:gridCol w="2903220"/>
-                <a:gridCol w="2903220"/>
+                <a:gridCol w="2903220">
+                  <a:extLst>
+                    <a:ext uri="{9D8B030D-6E8A-4147-A177-3AD203B41FA5}">
+                      <a16:colId xmlns:a16="http://schemas.microsoft.com/office/drawing/2014/main" val="20000"/>
+                    </a:ext>
+                  </a:extLst>
+                </a:gridCol>
+                <a:gridCol w="2903220">
+                  <a:extLst>
+                    <a:ext uri="{9D8B030D-6E8A-4147-A177-3AD203B41FA5}">
+                      <a16:colId xmlns:a16="http://schemas.microsoft.com/office/drawing/2014/main" val="20001"/>
+                    </a:ext>
+                  </a:extLst>
+                </a:gridCol>
+                <a:gridCol w="2903220">
+                  <a:extLst>
+                    <a:ext uri="{9D8B030D-6E8A-4147-A177-3AD203B41FA5}">
+                      <a16:colId xmlns:a16="http://schemas.microsoft.com/office/drawing/2014/main" val="20002"/>
+                    </a:ext>
+                  </a:extLst>
+                </a:gridCol>
+                <a:gridCol w="2903220">
+                  <a:extLst>
+                    <a:ext uri="{9D8B030D-6E8A-4147-A177-3AD203B41FA5}">
+                      <a16:colId xmlns:a16="http://schemas.microsoft.com/office/drawing/2014/main" val="20003"/>
+                    </a:ext>
+                  </a:extLst>
+                </a:gridCol>
               </a:tblGrid>
               <a:tr h="744582">
                 <a:tc>
@@ -7456,6 +8208,11 @@
                     </a:solidFill>
                   </a:tcPr>
                 </a:tc>
+                <a:extLst>
+                  <a:ext uri="{0D108BD9-81ED-4DB2-BD59-A6C34878D82A}">
+                    <a16:rowId xmlns:a16="http://schemas.microsoft.com/office/drawing/2014/main" val="10000"/>
+                  </a:ext>
+                </a:extLst>
               </a:tr>
               <a:tr h="744582">
                 <a:tc>
@@ -7549,6 +8306,11 @@
                     </a:solidFill>
                   </a:tcPr>
                 </a:tc>
+                <a:extLst>
+                  <a:ext uri="{0D108BD9-81ED-4DB2-BD59-A6C34878D82A}">
+                    <a16:rowId xmlns:a16="http://schemas.microsoft.com/office/drawing/2014/main" val="10001"/>
+                  </a:ext>
+                </a:extLst>
               </a:tr>
               <a:tr h="744582">
                 <a:tc>
@@ -7642,6 +8404,11 @@
                     </a:solidFill>
                   </a:tcPr>
                 </a:tc>
+                <a:extLst>
+                  <a:ext uri="{0D108BD9-81ED-4DB2-BD59-A6C34878D82A}">
+                    <a16:rowId xmlns:a16="http://schemas.microsoft.com/office/drawing/2014/main" val="10002"/>
+                  </a:ext>
+                </a:extLst>
               </a:tr>
               <a:tr h="744582">
                 <a:tc>
@@ -7735,6 +8502,11 @@
                     </a:solidFill>
                   </a:tcPr>
                 </a:tc>
+                <a:extLst>
+                  <a:ext uri="{0D108BD9-81ED-4DB2-BD59-A6C34878D82A}">
+                    <a16:rowId xmlns:a16="http://schemas.microsoft.com/office/drawing/2014/main" val="10003"/>
+                  </a:ext>
+                </a:extLst>
               </a:tr>
               <a:tr h="744582">
                 <a:tc>
@@ -7828,6 +8600,11 @@
                     </a:solidFill>
                   </a:tcPr>
                 </a:tc>
+                <a:extLst>
+                  <a:ext uri="{0D108BD9-81ED-4DB2-BD59-A6C34878D82A}">
+                    <a16:rowId xmlns:a16="http://schemas.microsoft.com/office/drawing/2014/main" val="10004"/>
+                  </a:ext>
+                </a:extLst>
               </a:tr>
               <a:tr h="744582">
                 <a:tc>
@@ -7837,7 +8614,7 @@
                     <a:p>
                       <a:pPr algn="ctr"/>
                       <a:r>
-                        <a:rPr sz="1400">
+                        <a:rPr sz="1400" dirty="0">
                           <a:solidFill>
                             <a:srgbClr val="000000"/>
                           </a:solidFill>
@@ -7920,6 +8697,11 @@
                     </a:solidFill>
                   </a:tcPr>
                 </a:tc>
+                <a:extLst>
+                  <a:ext uri="{0D108BD9-81ED-4DB2-BD59-A6C34878D82A}">
+                    <a16:rowId xmlns:a16="http://schemas.microsoft.com/office/drawing/2014/main" val="10005"/>
+                  </a:ext>
+                </a:extLst>
               </a:tr>
               <a:tr h="744588">
                 <a:tc>
@@ -7996,7 +8778,7 @@
                     <a:p>
                       <a:pPr algn="ctr"/>
                       <a:r>
-                        <a:rPr sz="1400">
+                        <a:rPr sz="1400" dirty="0">
                           <a:solidFill>
                             <a:srgbClr val="000000"/>
                           </a:solidFill>
@@ -8012,6 +8794,11 @@
                     </a:solidFill>
                   </a:tcPr>
                 </a:tc>
+                <a:extLst>
+                  <a:ext uri="{0D108BD9-81ED-4DB2-BD59-A6C34878D82A}">
+                    <a16:rowId xmlns:a16="http://schemas.microsoft.com/office/drawing/2014/main" val="10006"/>
+                  </a:ext>
+                </a:extLst>
               </a:tr>
             </a:tbl>
           </a:graphicData>

</xml_diff>